<commit_message>
feat: expand VineWeave presentation with fuller analysis and planting strategy
</commit_message>
<xml_diff>
--- a/presentation/v1/VineWeave-Canopy-v1.pptx
+++ b/presentation/v1/VineWeave-Canopy-v1.pptx
@@ -1904,13 +1904,13 @@
             <a:r>
               <a:rPr lang="en-US" dirty="0"/>
               <a:t>TAKEAWAY
-Five complementary roles connect design, analysis and presentation.
+VineWeave Canopy is the title and central subject; team credits are secondary.
 SPOKEN SCRIPT
-We are presenting VineWeave Canopy as an integrated group project. Our work connects form and parametric modelling, materials and construction, and shading and application. Presentation production and English delivery bring these three design modules together. This first slide records each member’s responsibility.
+We present VineWeave Canopy, a tree-like support system combining climbing plants with pedestrian shade. Our work connects parametric geometry, material and construction choices, and shading performance. The team responsibilities are summarised below. We begin with the public-space problem and the design goals.
 TRANSITION
 First, the public-space problem.
 Q&amp;A
-Are all listed outcomes validated? These are team responsibilities; the following slides distinguish completed analysis from proposed work.</a:t>
+Where are the detailed responsibilities? The names and core roles remain on the cover; the supplied allocation and planning document retain the full task descriptions.</a:t>
             </a:r>
             <a:endParaRPr lang="en-US" dirty="0"/>
           </a:p>
@@ -4128,24 +4128,24 @@
         </p:nvSpPr>
         <p:spPr>
           <a:xfrm>
-            <a:off x="530352" y="237744"/>
-            <a:ext cx="3657600" cy="228600"/>
-          </a:xfrm>
-          <a:prstGeom prst="rect">
-            <a:avLst/>
-          </a:prstGeom>
-          <a:noFill/>
-          <a:ln/>
-        </p:spPr>
-        <p:txBody>
-          <a:bodyPr wrap="square" lIns="0" tIns="0" rIns="0" bIns="0" rtlCol="0" anchor="ctr"/>
-          <a:lstStyle/>
-          <a:p>
-            <a:pPr indent="0" marL="0">
-              <a:buNone/>
-            </a:pPr>
-            <a:r>
-              <a:rPr lang="en-US" sz="1100" b="1" spc="180" kern="0" dirty="0">
+            <a:off x="603504" y="283464"/>
+            <a:ext cx="3657600" cy="246888"/>
+          </a:xfrm>
+          <a:prstGeom prst="rect">
+            <a:avLst/>
+          </a:prstGeom>
+          <a:noFill/>
+          <a:ln/>
+        </p:spPr>
+        <p:txBody>
+          <a:bodyPr wrap="square" lIns="0" tIns="0" rIns="0" bIns="0" rtlCol="0" anchor="ctr"/>
+          <a:lstStyle/>
+          <a:p>
+            <a:pPr indent="0" marL="0">
+              <a:buNone/>
+            </a:pPr>
+            <a:r>
+              <a:rPr lang="en-US" sz="1200" b="1" spc="170" kern="0" dirty="0">
                 <a:solidFill>
                   <a:srgbClr val="346A55"/>
                 </a:solidFill>
@@ -4155,65 +4155,65 @@
               </a:rPr>
               <a:t>GREEN BUILDING</a:t>
             </a:r>
+            <a:endParaRPr lang="en-US" sz="1200" dirty="0"/>
+          </a:p>
+        </p:txBody>
+      </p:sp>
+      <p:sp>
+        <p:nvSpPr>
+          <p:cNvPr id="8" name="Text 6"/>
+          <p:cNvSpPr/>
+          <p:nvPr/>
+        </p:nvSpPr>
+        <p:spPr>
+          <a:xfrm>
+            <a:off x="9372600" y="283464"/>
+            <a:ext cx="1920240" cy="228600"/>
+          </a:xfrm>
+          <a:prstGeom prst="rect">
+            <a:avLst/>
+          </a:prstGeom>
+          <a:noFill/>
+          <a:ln/>
+        </p:spPr>
+        <p:txBody>
+          <a:bodyPr wrap="square" lIns="0" tIns="0" rIns="0" bIns="0" rtlCol="0" anchor="ctr"/>
+          <a:lstStyle/>
+          <a:p>
+            <a:pPr algn="r" indent="0" marL="0">
+              <a:buNone/>
+            </a:pPr>
+            <a:r>
+              <a:rPr lang="en-US" sz="1100" spc="100" kern="0" dirty="0">
+                <a:solidFill>
+                  <a:srgbClr val="66736D"/>
+                </a:solidFill>
+                <a:latin typeface="Noto Sans" pitchFamily="34" charset="0"/>
+                <a:ea typeface="Noto Sans" pitchFamily="34" charset="-122"/>
+                <a:cs typeface="Noto Sans" pitchFamily="34" charset="-120"/>
+              </a:rPr>
+              <a:t>GROUP 12</a:t>
+            </a:r>
             <a:endParaRPr lang="en-US" sz="1100" dirty="0"/>
           </a:p>
         </p:txBody>
       </p:sp>
       <p:sp>
         <p:nvSpPr>
-          <p:cNvPr id="8" name="Text 6"/>
-          <p:cNvSpPr/>
-          <p:nvPr/>
-        </p:nvSpPr>
-        <p:spPr>
-          <a:xfrm>
-            <a:off x="7315200" y="237744"/>
-            <a:ext cx="3977640" cy="228600"/>
-          </a:xfrm>
-          <a:prstGeom prst="rect">
-            <a:avLst/>
-          </a:prstGeom>
-          <a:noFill/>
-          <a:ln/>
-        </p:spPr>
-        <p:txBody>
-          <a:bodyPr wrap="square" lIns="0" tIns="0" rIns="0" bIns="0" rtlCol="0" anchor="ctr"/>
-          <a:lstStyle/>
-          <a:p>
-            <a:pPr algn="r" indent="0" marL="0">
-              <a:buNone/>
-            </a:pPr>
-            <a:r>
-              <a:rPr lang="en-US" sz="1000" spc="100" kern="0" dirty="0">
-                <a:solidFill>
-                  <a:srgbClr val="66736D"/>
-                </a:solidFill>
-                <a:latin typeface="Noto Sans" pitchFamily="34" charset="0"/>
-                <a:ea typeface="Noto Sans" pitchFamily="34" charset="-122"/>
-                <a:cs typeface="Noto Sans" pitchFamily="34" charset="-120"/>
-              </a:rPr>
-              <a:t>TEAM</a:t>
-            </a:r>
-            <a:endParaRPr lang="en-US" sz="1000" dirty="0"/>
-          </a:p>
-        </p:txBody>
-      </p:sp>
-      <p:sp>
-        <p:nvSpPr>
           <p:cNvPr id="9" name="Shape 7"/>
           <p:cNvSpPr/>
           <p:nvPr/>
         </p:nvSpPr>
         <p:spPr>
           <a:xfrm>
-            <a:off x="530352" y="694944"/>
-            <a:ext cx="11100816" cy="0"/>
+            <a:off x="603504" y="758952"/>
+            <a:ext cx="10972800" cy="0"/>
           </a:xfrm>
           <a:prstGeom prst="line">
             <a:avLst/>
           </a:prstGeom>
           <a:noFill/>
-          <a:ln w="8890">
+          <a:ln w="10160">
             <a:solidFill>
               <a:srgbClr val="AA7E4A"/>
             </a:solidFill>
@@ -4229,24 +4229,24 @@
         </p:nvSpPr>
         <p:spPr>
           <a:xfrm>
-            <a:off x="530352" y="859536"/>
-            <a:ext cx="10972800" cy="585216"/>
-          </a:xfrm>
-          <a:prstGeom prst="rect">
-            <a:avLst/>
-          </a:prstGeom>
-          <a:noFill/>
-          <a:ln/>
-        </p:spPr>
-        <p:txBody>
-          <a:bodyPr wrap="square" lIns="0" tIns="0" rIns="0" bIns="0" rtlCol="0" anchor="ctr"/>
-          <a:lstStyle/>
-          <a:p>
-            <a:pPr indent="0" marL="0">
-              <a:buNone/>
-            </a:pPr>
-            <a:r>
-              <a:rPr lang="en-US" sz="2900" b="1" dirty="0">
+            <a:off x="621792" y="1417320"/>
+            <a:ext cx="6583680" cy="1691640"/>
+          </a:xfrm>
+          <a:prstGeom prst="rect">
+            <a:avLst/>
+          </a:prstGeom>
+          <a:noFill/>
+          <a:ln/>
+        </p:spPr>
+        <p:txBody>
+          <a:bodyPr wrap="square" lIns="0" tIns="0" rIns="0" bIns="0" rtlCol="0" anchor="ctr"/>
+          <a:lstStyle/>
+          <a:p>
+            <a:pPr indent="0" marL="0">
+              <a:buNone/>
+            </a:pPr>
+            <a:r>
+              <a:rPr lang="en-US" sz="4900" b="1" dirty="0">
                 <a:solidFill>
                   <a:srgbClr val="173C51"/>
                 </a:solidFill>
@@ -4254,9 +4254,26 @@
                 <a:ea typeface="Noto Serif" pitchFamily="34" charset="-122"/>
                 <a:cs typeface="Noto Serif" pitchFamily="34" charset="-120"/>
               </a:rPr>
-              <a:t>VineWeave Canopy</a:t>
-            </a:r>
-            <a:endParaRPr lang="en-US" sz="2900" dirty="0"/>
+              <a:t>VineWeave</a:t>
+            </a:r>
+            <a:endParaRPr lang="en-US" sz="4900" dirty="0"/>
+          </a:p>
+          <a:p>
+            <a:pPr indent="0" marL="0">
+              <a:buNone/>
+            </a:pPr>
+            <a:r>
+              <a:rPr lang="en-US" sz="4900" b="1" dirty="0">
+                <a:solidFill>
+                  <a:srgbClr val="173C51"/>
+                </a:solidFill>
+                <a:latin typeface="Noto Serif" pitchFamily="34" charset="0"/>
+                <a:ea typeface="Noto Serif" pitchFamily="34" charset="-122"/>
+                <a:cs typeface="Noto Serif" pitchFamily="34" charset="-120"/>
+              </a:rPr>
+              <a:t>Canopy</a:t>
+            </a:r>
+            <a:endParaRPr lang="en-US" sz="4900" dirty="0"/>
           </a:p>
         </p:txBody>
       </p:sp>
@@ -4268,53 +4285,133 @@
         </p:nvSpPr>
         <p:spPr>
           <a:xfrm>
-            <a:off x="557784" y="1481328"/>
-            <a:ext cx="10927080" cy="393192"/>
-          </a:xfrm>
-          <a:prstGeom prst="rect">
-            <a:avLst/>
-          </a:prstGeom>
-          <a:noFill/>
-          <a:ln/>
-        </p:spPr>
-        <p:txBody>
-          <a:bodyPr wrap="square" lIns="0" tIns="0" rIns="0" bIns="0" rtlCol="0" anchor="ctr"/>
-          <a:lstStyle/>
-          <a:p>
-            <a:pPr indent="0" marL="0">
-              <a:buNone/>
-            </a:pPr>
-            <a:r>
-              <a:rPr lang="en-US" sz="1500" dirty="0">
-                <a:solidFill>
-                  <a:srgbClr val="66736D"/>
-                </a:solidFill>
-                <a:latin typeface="Noto Sans" pitchFamily="34" charset="0"/>
-                <a:ea typeface="Noto Sans" pitchFamily="34" charset="-122"/>
-                <a:cs typeface="Noto Sans" pitchFamily="34" charset="-120"/>
-              </a:rPr>
-              <a:t>A tree-like support system for climbing plants and pedestrian shade</a:t>
-            </a:r>
-            <a:endParaRPr lang="en-US" sz="1500" dirty="0"/>
-          </a:p>
-        </p:txBody>
-      </p:sp>
-      <p:sp>
-        <p:nvSpPr>
-          <p:cNvPr id="12" name="Shape 10"/>
-          <p:cNvSpPr/>
-          <p:nvPr/>
-        </p:nvSpPr>
-        <p:spPr>
-          <a:xfrm>
-            <a:off x="530352" y="6437376"/>
-            <a:ext cx="11100816" cy="0"/>
+            <a:off x="667512" y="3337560"/>
+            <a:ext cx="6080760" cy="822960"/>
+          </a:xfrm>
+          <a:prstGeom prst="rect">
+            <a:avLst/>
+          </a:prstGeom>
+          <a:noFill/>
+          <a:ln/>
+        </p:spPr>
+        <p:txBody>
+          <a:bodyPr wrap="square" lIns="0" tIns="0" rIns="0" bIns="0" rtlCol="0" anchor="ctr"/>
+          <a:lstStyle/>
+          <a:p>
+            <a:pPr indent="0" marL="0">
+              <a:buNone/>
+            </a:pPr>
+            <a:r>
+              <a:rPr lang="en-US" sz="2300" dirty="0">
+                <a:solidFill>
+                  <a:srgbClr val="34434A"/>
+                </a:solidFill>
+                <a:latin typeface="Noto Sans" pitchFamily="34" charset="0"/>
+                <a:ea typeface="Noto Sans" pitchFamily="34" charset="-122"/>
+                <a:cs typeface="Noto Sans" pitchFamily="34" charset="-120"/>
+              </a:rPr>
+              <a:t>A tree-like support system for climbing plants</a:t>
+            </a:r>
+            <a:endParaRPr lang="en-US" sz="2300" dirty="0"/>
+          </a:p>
+          <a:p>
+            <a:pPr indent="0" marL="0">
+              <a:buNone/>
+            </a:pPr>
+            <a:r>
+              <a:rPr lang="en-US" sz="2300" dirty="0">
+                <a:solidFill>
+                  <a:srgbClr val="34434A"/>
+                </a:solidFill>
+                <a:latin typeface="Noto Sans" pitchFamily="34" charset="0"/>
+                <a:ea typeface="Noto Sans" pitchFamily="34" charset="-122"/>
+                <a:cs typeface="Noto Sans" pitchFamily="34" charset="-120"/>
+              </a:rPr>
+              <a:t>and pedestrian shade</a:t>
+            </a:r>
+            <a:endParaRPr lang="en-US" sz="2300" dirty="0"/>
+          </a:p>
+        </p:txBody>
+      </p:sp>
+      <p:sp>
+        <p:nvSpPr>
+          <p:cNvPr id="12" name="Text 10"/>
+          <p:cNvSpPr/>
+          <p:nvPr/>
+        </p:nvSpPr>
+        <p:spPr>
+          <a:xfrm>
+            <a:off x="685800" y="4489704"/>
+            <a:ext cx="5760720" cy="320040"/>
+          </a:xfrm>
+          <a:prstGeom prst="rect">
+            <a:avLst/>
+          </a:prstGeom>
+          <a:noFill/>
+          <a:ln/>
+        </p:spPr>
+        <p:txBody>
+          <a:bodyPr wrap="square" lIns="0" tIns="0" rIns="0" bIns="0" rtlCol="0" anchor="ctr"/>
+          <a:lstStyle/>
+          <a:p>
+            <a:pPr indent="0" marL="0">
+              <a:buNone/>
+            </a:pPr>
+            <a:r>
+              <a:rPr lang="en-US" sz="1400" dirty="0">
+                <a:solidFill>
+                  <a:srgbClr val="346A55"/>
+                </a:solidFill>
+                <a:latin typeface="Noto Sans" pitchFamily="34" charset="0"/>
+                <a:ea typeface="Noto Sans" pitchFamily="34" charset="-122"/>
+                <a:cs typeface="Noto Sans" pitchFamily="34" charset="-120"/>
+              </a:rPr>
+              <a:t>Parametric design  ·  Planting  ·  Shade performance</a:t>
+            </a:r>
+            <a:endParaRPr lang="en-US" sz="1400" dirty="0"/>
+          </a:p>
+        </p:txBody>
+      </p:sp>
+      <p:pic>
+        <p:nvPicPr>
+          <p:cNvPr id="13" name="Image 0" descr="/workspace/temp/presentation/v1/assets/model-axon.png">    </p:cNvPr>
+          <p:cNvPicPr>
+            <a:picLocks noChangeAspect="1"/>
+          </p:cNvPicPr>
+          <p:nvPr/>
+        </p:nvPicPr>
+        <p:blipFill>
+          <a:blip r:embed="rId1"/>
+          <a:stretch>
+            <a:fillRect/>
+          </a:stretch>
+        </p:blipFill>
+        <p:spPr>
+          <a:xfrm>
+            <a:off x="6784848" y="1495172"/>
+            <a:ext cx="4791456" cy="3465320"/>
+          </a:xfrm>
+          <a:prstGeom prst="rect">
+            <a:avLst/>
+          </a:prstGeom>
+        </p:spPr>
+      </p:pic>
+      <p:sp>
+        <p:nvSpPr>
+          <p:cNvPr id="14" name="Shape 11"/>
+          <p:cNvSpPr/>
+          <p:nvPr/>
+        </p:nvSpPr>
+        <p:spPr>
+          <a:xfrm>
+            <a:off x="612648" y="5239512"/>
+            <a:ext cx="10963656" cy="0"/>
           </a:xfrm>
           <a:prstGeom prst="line">
             <a:avLst/>
           </a:prstGeom>
           <a:noFill/>
-          <a:ln w="7620">
+          <a:ln w="10160">
             <a:solidFill>
               <a:srgbClr val="D9DDD2"/>
             </a:solidFill>
@@ -4324,30 +4421,30 @@
       </p:sp>
       <p:sp>
         <p:nvSpPr>
-          <p:cNvPr id="13" name="Text 11"/>
-          <p:cNvSpPr/>
-          <p:nvPr/>
-        </p:nvSpPr>
-        <p:spPr>
-          <a:xfrm>
-            <a:off x="548640" y="6510528"/>
-            <a:ext cx="10561320" cy="192024"/>
-          </a:xfrm>
-          <a:prstGeom prst="rect">
-            <a:avLst/>
-          </a:prstGeom>
-          <a:noFill/>
-          <a:ln/>
-        </p:spPr>
-        <p:txBody>
-          <a:bodyPr wrap="square" lIns="0" tIns="0" rIns="0" bIns="0" rtlCol="0" anchor="ctr"/>
-          <a:lstStyle/>
-          <a:p>
-            <a:pPr indent="0" marL="0">
-              <a:buNone/>
-            </a:pPr>
-            <a:r>
-              <a:rPr lang="en-US" sz="1060" dirty="0">
+          <p:cNvPr id="15" name="Text 12"/>
+          <p:cNvSpPr/>
+          <p:nvPr/>
+        </p:nvSpPr>
+        <p:spPr>
+          <a:xfrm>
+            <a:off x="667512" y="5385816"/>
+            <a:ext cx="4572000" cy="201168"/>
+          </a:xfrm>
+          <a:prstGeom prst="rect">
+            <a:avLst/>
+          </a:prstGeom>
+          <a:noFill/>
+          <a:ln/>
+        </p:spPr>
+        <p:txBody>
+          <a:bodyPr wrap="square" lIns="0" tIns="0" rIns="0" bIns="0" rtlCol="0" anchor="ctr"/>
+          <a:lstStyle/>
+          <a:p>
+            <a:pPr indent="0" marL="0">
+              <a:buNone/>
+            </a:pPr>
+            <a:r>
+              <a:rPr lang="en-US" sz="1050" b="1" spc="100" kern="0" dirty="0">
                 <a:solidFill>
                   <a:srgbClr val="66736D"/>
                 </a:solidFill>
@@ -4355,1423 +4452,487 @@
                 <a:ea typeface="Noto Sans" pitchFamily="34" charset="-122"/>
                 <a:cs typeface="Noto Sans" pitchFamily="34" charset="-120"/>
               </a:rPr>
-              <a:t>Team responsibilities follow the supplied group allocation.</a:t>
-            </a:r>
-            <a:endParaRPr lang="en-US" sz="1060" dirty="0"/>
-          </a:p>
-        </p:txBody>
-      </p:sp>
-      <p:sp>
-        <p:nvSpPr>
-          <p:cNvPr id="14" name="Text 12"/>
-          <p:cNvSpPr/>
-          <p:nvPr/>
-        </p:nvSpPr>
-        <p:spPr>
-          <a:xfrm>
-            <a:off x="11155680" y="6501384"/>
-            <a:ext cx="438912" cy="201168"/>
-          </a:xfrm>
-          <a:prstGeom prst="rect">
-            <a:avLst/>
-          </a:prstGeom>
-          <a:noFill/>
-          <a:ln/>
-        </p:spPr>
-        <p:txBody>
-          <a:bodyPr wrap="square" lIns="0" tIns="0" rIns="0" bIns="0" rtlCol="0" anchor="ctr"/>
-          <a:lstStyle/>
-          <a:p>
-            <a:pPr algn="r" indent="0" marL="0">
-              <a:buNone/>
-            </a:pPr>
-            <a:r>
-              <a:rPr lang="en-US" sz="1000" b="1" dirty="0">
+              <a:t>TEAM &amp; RESPONSIBILITIES</a:t>
+            </a:r>
+            <a:endParaRPr lang="en-US" sz="1050" dirty="0"/>
+          </a:p>
+        </p:txBody>
+      </p:sp>
+      <p:sp>
+        <p:nvSpPr>
+          <p:cNvPr id="16" name="Text 13"/>
+          <p:cNvSpPr/>
+          <p:nvPr/>
+        </p:nvSpPr>
+        <p:spPr>
+          <a:xfrm>
+            <a:off x="685800" y="5696712"/>
+            <a:ext cx="2048256" cy="292608"/>
+          </a:xfrm>
+          <a:prstGeom prst="rect">
+            <a:avLst/>
+          </a:prstGeom>
+          <a:noFill/>
+          <a:ln/>
+        </p:spPr>
+        <p:txBody>
+          <a:bodyPr wrap="square" lIns="0" tIns="0" rIns="0" bIns="0" rtlCol="0" anchor="ctr"/>
+          <a:lstStyle/>
+          <a:p>
+            <a:pPr indent="0" marL="0">
+              <a:buNone/>
+            </a:pPr>
+            <a:r>
+              <a:rPr lang="en-US" sz="1700" b="1" dirty="0">
                 <a:solidFill>
                   <a:srgbClr val="346A55"/>
                 </a:solidFill>
-                <a:latin typeface="Noto Sans" pitchFamily="34" charset="0"/>
-                <a:ea typeface="Noto Sans" pitchFamily="34" charset="-122"/>
-                <a:cs typeface="Noto Sans" pitchFamily="34" charset="-120"/>
-              </a:rPr>
-              <a:t>01</a:t>
-            </a:r>
-            <a:endParaRPr lang="en-US" sz="1000" dirty="0"/>
-          </a:p>
-        </p:txBody>
-      </p:sp>
-      <p:graphicFrame>
-        <p:nvGraphicFramePr>
-          <p:cNvPr id="2" name="Table 0"/>
-          <p:cNvGraphicFramePr>
-            <a:graphicFrameLocks noGrp="1"/>
-          </p:cNvGraphicFramePr>
-          <p:nvPr>
-            <p:extLst>
-              <p:ext uri="{D42A27DB-BD31-4B8C-83A1-F6EECF244321}">
-                <p14:modId xmlns:p14="http://schemas.microsoft.com/office/powerpoint/2010/main" val="1579011935"/>
-              </p:ext>
-            </p:extLst>
-          </p:nvPr>
-        </p:nvGraphicFramePr>
-        <p:xfrm>
-          <a:off x="566928" y="1993392"/>
-          <a:ext cx="11027664" cy="4069080"/>
-        </p:xfrm>
-        <a:graphic>
-          <a:graphicData uri="http://schemas.openxmlformats.org/drawingml/2006/table">
-            <a:tbl>
-              <a:tblPr/>
-              <a:tblGrid>
-                <a:gridCol w="1280160"/>
-                <a:gridCol w="5715000"/>
-                <a:gridCol w="4032504"/>
-              </a:tblGrid>
-              <a:tr h="393192">
-                <a:tc>
-                  <a:txBody>
-                    <a:bodyPr/>
-                    <a:lstStyle/>
-                    <a:p>
-                      <a:pPr indent="0" marL="0">
-                        <a:buNone/>
-                      </a:pPr>
-                      <a:r>
-                        <a:rPr lang="en-US" sz="1550" b="1" dirty="0">
-                          <a:solidFill>
-                            <a:srgbClr val="34434A"/>
-                          </a:solidFill>
-                          <a:latin typeface="Noto Sans CJK SC" pitchFamily="34" charset="0"/>
-                          <a:ea typeface="Noto Sans CJK SC" pitchFamily="34" charset="-122"/>
-                          <a:cs typeface="Noto Sans CJK SC" pitchFamily="34" charset="-120"/>
-                        </a:rPr>
-                        <a:t>MEMBER</a:t>
-                      </a:r>
-                      <a:endParaRPr lang="en-US" sz="1550" dirty="0">
-                        <a:latin typeface="Noto Sans CJK SC" charset="0"/>
-                        <a:ea typeface="Noto Sans CJK SC" charset="0"/>
-                        <a:cs typeface="Noto Sans CJK SC" charset="0"/>
-                      </a:endParaRPr>
-                    </a:p>
-                  </a:txBody>
-                  <a:tcPr marL="127000" marR="127000" marT="88900" marB="88900" anchor="mid">
-                    <a:lnL w="7620" cap="flat" cmpd="sng" algn="ctr">
-                      <a:solidFill>
-                        <a:srgbClr val="D9DDD2"/>
-                      </a:solidFill>
-                      <a:prstDash val="solid"/>
-                      <a:round/>
-                      <a:headEnd type="none" w="med" len="med"/>
-                      <a:tailEnd type="none" w="med" len="med"/>
-                    </a:lnL>
-                    <a:lnR w="7620" cap="flat" cmpd="sng" algn="ctr">
-                      <a:solidFill>
-                        <a:srgbClr val="D9DDD2"/>
-                      </a:solidFill>
-                      <a:prstDash val="solid"/>
-                      <a:round/>
-                      <a:headEnd type="none" w="med" len="med"/>
-                      <a:tailEnd type="none" w="med" len="med"/>
-                    </a:lnR>
-                    <a:lnT w="7620" cap="flat" cmpd="sng" algn="ctr">
-                      <a:solidFill>
-                        <a:srgbClr val="D9DDD2"/>
-                      </a:solidFill>
-                      <a:prstDash val="solid"/>
-                      <a:round/>
-                      <a:headEnd type="none" w="med" len="med"/>
-                      <a:tailEnd type="none" w="med" len="med"/>
-                    </a:lnT>
-                    <a:lnB w="7620" cap="flat" cmpd="sng" algn="ctr">
-                      <a:solidFill>
-                        <a:srgbClr val="D9DDD2"/>
-                      </a:solidFill>
-                      <a:prstDash val="solid"/>
-                      <a:round/>
-                      <a:headEnd type="none" w="med" len="med"/>
-                      <a:tailEnd type="none" w="med" len="med"/>
-                    </a:lnB>
-                    <a:solidFill>
-                      <a:srgbClr val="F8F7F2"/>
-                    </a:solidFill>
-                  </a:tcPr>
-                </a:tc>
-                <a:tc>
-                  <a:txBody>
-                    <a:bodyPr/>
-                    <a:lstStyle/>
-                    <a:p>
-                      <a:pPr indent="0" marL="0">
-                        <a:buNone/>
-                      </a:pPr>
-                      <a:r>
-                        <a:rPr lang="en-US" sz="1550" b="1" dirty="0">
-                          <a:solidFill>
-                            <a:srgbClr val="34434A"/>
-                          </a:solidFill>
-                          <a:latin typeface="Noto Sans CJK SC" pitchFamily="34" charset="0"/>
-                          <a:ea typeface="Noto Sans CJK SC" pitchFamily="34" charset="-122"/>
-                          <a:cs typeface="Noto Sans CJK SC" pitchFamily="34" charset="-120"/>
-                        </a:rPr>
-                        <a:t>RESPONSIBILITY &amp; KEY WORK</a:t>
-                      </a:r>
-                      <a:endParaRPr lang="en-US" sz="1550" dirty="0">
-                        <a:latin typeface="Noto Sans CJK SC" charset="0"/>
-                        <a:ea typeface="Noto Sans CJK SC" charset="0"/>
-                        <a:cs typeface="Noto Sans CJK SC" charset="0"/>
-                      </a:endParaRPr>
-                    </a:p>
-                  </a:txBody>
-                  <a:tcPr marL="127000" marR="127000" marT="88900" marB="88900" anchor="mid">
-                    <a:lnL w="7620" cap="flat" cmpd="sng" algn="ctr">
-                      <a:solidFill>
-                        <a:srgbClr val="D9DDD2"/>
-                      </a:solidFill>
-                      <a:prstDash val="solid"/>
-                      <a:round/>
-                      <a:headEnd type="none" w="med" len="med"/>
-                      <a:tailEnd type="none" w="med" len="med"/>
-                    </a:lnL>
-                    <a:lnR w="7620" cap="flat" cmpd="sng" algn="ctr">
-                      <a:solidFill>
-                        <a:srgbClr val="D9DDD2"/>
-                      </a:solidFill>
-                      <a:prstDash val="solid"/>
-                      <a:round/>
-                      <a:headEnd type="none" w="med" len="med"/>
-                      <a:tailEnd type="none" w="med" len="med"/>
-                    </a:lnR>
-                    <a:lnT w="7620" cap="flat" cmpd="sng" algn="ctr">
-                      <a:solidFill>
-                        <a:srgbClr val="D9DDD2"/>
-                      </a:solidFill>
-                      <a:prstDash val="solid"/>
-                      <a:round/>
-                      <a:headEnd type="none" w="med" len="med"/>
-                      <a:tailEnd type="none" w="med" len="med"/>
-                    </a:lnT>
-                    <a:lnB w="7620" cap="flat" cmpd="sng" algn="ctr">
-                      <a:solidFill>
-                        <a:srgbClr val="D9DDD2"/>
-                      </a:solidFill>
-                      <a:prstDash val="solid"/>
-                      <a:round/>
-                      <a:headEnd type="none" w="med" len="med"/>
-                      <a:tailEnd type="none" w="med" len="med"/>
-                    </a:lnB>
-                    <a:solidFill>
-                      <a:srgbClr val="F8F7F2"/>
-                    </a:solidFill>
-                  </a:tcPr>
-                </a:tc>
-                <a:tc>
-                  <a:txBody>
-                    <a:bodyPr/>
-                    <a:lstStyle/>
-                    <a:p>
-                      <a:pPr indent="0" marL="0">
-                        <a:buNone/>
-                      </a:pPr>
-                      <a:r>
-                        <a:rPr lang="en-US" sz="1550" b="1" dirty="0">
-                          <a:solidFill>
-                            <a:srgbClr val="34434A"/>
-                          </a:solidFill>
-                          <a:latin typeface="Noto Sans CJK SC" pitchFamily="34" charset="0"/>
-                          <a:ea typeface="Noto Sans CJK SC" pitchFamily="34" charset="-122"/>
-                          <a:cs typeface="Noto Sans CJK SC" pitchFamily="34" charset="-120"/>
-                        </a:rPr>
-                        <a:t>DELIVERABLES</a:t>
-                      </a:r>
-                      <a:endParaRPr lang="en-US" sz="1550" dirty="0">
-                        <a:latin typeface="Noto Sans CJK SC" charset="0"/>
-                        <a:ea typeface="Noto Sans CJK SC" charset="0"/>
-                        <a:cs typeface="Noto Sans CJK SC" charset="0"/>
-                      </a:endParaRPr>
-                    </a:p>
-                  </a:txBody>
-                  <a:tcPr marL="127000" marR="127000" marT="88900" marB="88900" anchor="mid">
-                    <a:lnL w="7620" cap="flat" cmpd="sng" algn="ctr">
-                      <a:solidFill>
-                        <a:srgbClr val="D9DDD2"/>
-                      </a:solidFill>
-                      <a:prstDash val="solid"/>
-                      <a:round/>
-                      <a:headEnd type="none" w="med" len="med"/>
-                      <a:tailEnd type="none" w="med" len="med"/>
-                    </a:lnL>
-                    <a:lnR w="7620" cap="flat" cmpd="sng" algn="ctr">
-                      <a:solidFill>
-                        <a:srgbClr val="D9DDD2"/>
-                      </a:solidFill>
-                      <a:prstDash val="solid"/>
-                      <a:round/>
-                      <a:headEnd type="none" w="med" len="med"/>
-                      <a:tailEnd type="none" w="med" len="med"/>
-                    </a:lnR>
-                    <a:lnT w="7620" cap="flat" cmpd="sng" algn="ctr">
-                      <a:solidFill>
-                        <a:srgbClr val="D9DDD2"/>
-                      </a:solidFill>
-                      <a:prstDash val="solid"/>
-                      <a:round/>
-                      <a:headEnd type="none" w="med" len="med"/>
-                      <a:tailEnd type="none" w="med" len="med"/>
-                    </a:lnT>
-                    <a:lnB w="7620" cap="flat" cmpd="sng" algn="ctr">
-                      <a:solidFill>
-                        <a:srgbClr val="D9DDD2"/>
-                      </a:solidFill>
-                      <a:prstDash val="solid"/>
-                      <a:round/>
-                      <a:headEnd type="none" w="med" len="med"/>
-                      <a:tailEnd type="none" w="med" len="med"/>
-                    </a:lnB>
-                    <a:solidFill>
-                      <a:srgbClr val="F8F7F2"/>
-                    </a:solidFill>
-                  </a:tcPr>
-                </a:tc>
-              </a:tr>
-              <a:tr h="713232">
-                <a:tc>
-                  <a:txBody>
-                    <a:bodyPr/>
-                    <a:lstStyle/>
-                    <a:p>
-                      <a:pPr indent="0" marL="0">
-                        <a:buNone/>
-                      </a:pPr>
-                      <a:r>
-                        <a:rPr lang="en-US" sz="1550" dirty="0">
-                          <a:solidFill>
-                            <a:srgbClr val="34434A"/>
-                          </a:solidFill>
-                          <a:latin typeface="Noto Sans CJK SC" pitchFamily="34" charset="0"/>
-                          <a:ea typeface="Noto Sans CJK SC" pitchFamily="34" charset="-122"/>
-                          <a:cs typeface="Noto Sans CJK SC" pitchFamily="34" charset="-120"/>
-                        </a:rPr>
-                        <a:t>臧唯羽</a:t>
-                      </a:r>
-                      <a:endParaRPr lang="en-US" sz="1550" dirty="0">
-                        <a:latin typeface="Noto Sans CJK SC" charset="0"/>
-                        <a:ea typeface="Noto Sans CJK SC" charset="0"/>
-                        <a:cs typeface="Noto Sans CJK SC" charset="0"/>
-                      </a:endParaRPr>
-                    </a:p>
-                  </a:txBody>
-                  <a:tcPr marL="127000" marR="127000" marT="88900" marB="88900" anchor="mid">
-                    <a:lnL w="7620" cap="flat" cmpd="sng" algn="ctr">
-                      <a:solidFill>
-                        <a:srgbClr val="D9DDD2"/>
-                      </a:solidFill>
-                      <a:prstDash val="solid"/>
-                      <a:round/>
-                      <a:headEnd type="none" w="med" len="med"/>
-                      <a:tailEnd type="none" w="med" len="med"/>
-                    </a:lnL>
-                    <a:lnR w="7620" cap="flat" cmpd="sng" algn="ctr">
-                      <a:solidFill>
-                        <a:srgbClr val="D9DDD2"/>
-                      </a:solidFill>
-                      <a:prstDash val="solid"/>
-                      <a:round/>
-                      <a:headEnd type="none" w="med" len="med"/>
-                      <a:tailEnd type="none" w="med" len="med"/>
-                    </a:lnR>
-                    <a:lnT w="7620" cap="flat" cmpd="sng" algn="ctr">
-                      <a:solidFill>
-                        <a:srgbClr val="D9DDD2"/>
-                      </a:solidFill>
-                      <a:prstDash val="solid"/>
-                      <a:round/>
-                      <a:headEnd type="none" w="med" len="med"/>
-                      <a:tailEnd type="none" w="med" len="med"/>
-                    </a:lnT>
-                    <a:lnB w="7620" cap="flat" cmpd="sng" algn="ctr">
-                      <a:solidFill>
-                        <a:srgbClr val="D9DDD2"/>
-                      </a:solidFill>
-                      <a:prstDash val="solid"/>
-                      <a:round/>
-                      <a:headEnd type="none" w="med" len="med"/>
-                      <a:tailEnd type="none" w="med" len="med"/>
-                    </a:lnB>
-                    <a:solidFill>
-                      <a:srgbClr val="F8F7F2"/>
-                    </a:solidFill>
-                  </a:tcPr>
-                </a:tc>
-                <a:tc>
-                  <a:txBody>
-                    <a:bodyPr/>
-                    <a:lstStyle/>
-                    <a:p>
-                      <a:pPr indent="0" marL="0">
-                        <a:buNone/>
-                      </a:pPr>
-                      <a:r>
-                        <a:rPr lang="en-US" sz="1550" dirty="0">
-                          <a:solidFill>
-                            <a:srgbClr val="34434A"/>
-                          </a:solidFill>
-                          <a:latin typeface="Noto Sans CJK SC" pitchFamily="34" charset="0"/>
-                          <a:ea typeface="Noto Sans CJK SC" pitchFamily="34" charset="-122"/>
-                          <a:cs typeface="Noto Sans CJK SC" pitchFamily="34" charset="-120"/>
-                        </a:rPr>
-                        <a:t>Design · Form and parametric modelling</a:t>
-                      </a:r>
-                      <a:endParaRPr lang="en-US" sz="1550" dirty="0">
-                        <a:latin typeface="Noto Sans CJK SC" charset="0"/>
-                        <a:ea typeface="Noto Sans CJK SC" charset="0"/>
-                        <a:cs typeface="Noto Sans CJK SC" charset="0"/>
-                      </a:endParaRPr>
-                    </a:p>
-                    <a:p>
-                      <a:pPr indent="0" marL="0">
-                        <a:buNone/>
-                      </a:pPr>
-                      <a:r>
-                        <a:rPr lang="en-US" sz="1550" dirty="0">
-                          <a:solidFill>
-                            <a:srgbClr val="34434A"/>
-                          </a:solidFill>
-                          <a:latin typeface="Noto Sans CJK SC" pitchFamily="34" charset="0"/>
-                          <a:ea typeface="Noto Sans CJK SC" pitchFamily="34" charset="-122"/>
-                          <a:cs typeface="Noto Sans CJK SC" pitchFamily="34" charset="-120"/>
-                        </a:rPr>
-                        <a:t>Rhino/Grasshopper; geometry and drawings</a:t>
-                      </a:r>
-                      <a:endParaRPr lang="en-US" sz="1550" dirty="0">
-                        <a:latin typeface="Noto Sans CJK SC" charset="0"/>
-                        <a:ea typeface="Noto Sans CJK SC" charset="0"/>
-                        <a:cs typeface="Noto Sans CJK SC" charset="0"/>
-                      </a:endParaRPr>
-                    </a:p>
-                  </a:txBody>
-                  <a:tcPr marL="127000" marR="127000" marT="88900" marB="88900" anchor="mid">
-                    <a:lnL w="7620" cap="flat" cmpd="sng" algn="ctr">
-                      <a:solidFill>
-                        <a:srgbClr val="D9DDD2"/>
-                      </a:solidFill>
-                      <a:prstDash val="solid"/>
-                      <a:round/>
-                      <a:headEnd type="none" w="med" len="med"/>
-                      <a:tailEnd type="none" w="med" len="med"/>
-                    </a:lnL>
-                    <a:lnR w="7620" cap="flat" cmpd="sng" algn="ctr">
-                      <a:solidFill>
-                        <a:srgbClr val="D9DDD2"/>
-                      </a:solidFill>
-                      <a:prstDash val="solid"/>
-                      <a:round/>
-                      <a:headEnd type="none" w="med" len="med"/>
-                      <a:tailEnd type="none" w="med" len="med"/>
-                    </a:lnR>
-                    <a:lnT w="7620" cap="flat" cmpd="sng" algn="ctr">
-                      <a:solidFill>
-                        <a:srgbClr val="D9DDD2"/>
-                      </a:solidFill>
-                      <a:prstDash val="solid"/>
-                      <a:round/>
-                      <a:headEnd type="none" w="med" len="med"/>
-                      <a:tailEnd type="none" w="med" len="med"/>
-                    </a:lnT>
-                    <a:lnB w="7620" cap="flat" cmpd="sng" algn="ctr">
-                      <a:solidFill>
-                        <a:srgbClr val="D9DDD2"/>
-                      </a:solidFill>
-                      <a:prstDash val="solid"/>
-                      <a:round/>
-                      <a:headEnd type="none" w="med" len="med"/>
-                      <a:tailEnd type="none" w="med" len="med"/>
-                    </a:lnB>
-                    <a:solidFill>
-                      <a:srgbClr val="F8F7F2"/>
-                    </a:solidFill>
-                  </a:tcPr>
-                </a:tc>
-                <a:tc>
-                  <a:txBody>
-                    <a:bodyPr/>
-                    <a:lstStyle/>
-                    <a:p>
-                      <a:pPr indent="0" marL="0">
-                        <a:buNone/>
-                      </a:pPr>
-                      <a:r>
-                        <a:rPr lang="en-US" sz="1550" dirty="0">
-                          <a:solidFill>
-                            <a:srgbClr val="34434A"/>
-                          </a:solidFill>
-                          <a:latin typeface="Noto Sans CJK SC" pitchFamily="34" charset="0"/>
-                          <a:ea typeface="Noto Sans CJK SC" pitchFamily="34" charset="-122"/>
-                          <a:cs typeface="Noto Sans CJK SC" pitchFamily="34" charset="-120"/>
-                        </a:rPr>
-                        <a:t>3D model; plans, elevations and parameter diagrams</a:t>
-                      </a:r>
-                      <a:endParaRPr lang="en-US" sz="1550" dirty="0">
-                        <a:latin typeface="Noto Sans CJK SC" charset="0"/>
-                        <a:ea typeface="Noto Sans CJK SC" charset="0"/>
-                        <a:cs typeface="Noto Sans CJK SC" charset="0"/>
-                      </a:endParaRPr>
-                    </a:p>
-                  </a:txBody>
-                  <a:tcPr marL="127000" marR="127000" marT="88900" marB="88900" anchor="mid">
-                    <a:lnL w="7620" cap="flat" cmpd="sng" algn="ctr">
-                      <a:solidFill>
-                        <a:srgbClr val="D9DDD2"/>
-                      </a:solidFill>
-                      <a:prstDash val="solid"/>
-                      <a:round/>
-                      <a:headEnd type="none" w="med" len="med"/>
-                      <a:tailEnd type="none" w="med" len="med"/>
-                    </a:lnL>
-                    <a:lnR w="7620" cap="flat" cmpd="sng" algn="ctr">
-                      <a:solidFill>
-                        <a:srgbClr val="D9DDD2"/>
-                      </a:solidFill>
-                      <a:prstDash val="solid"/>
-                      <a:round/>
-                      <a:headEnd type="none" w="med" len="med"/>
-                      <a:tailEnd type="none" w="med" len="med"/>
-                    </a:lnR>
-                    <a:lnT w="7620" cap="flat" cmpd="sng" algn="ctr">
-                      <a:solidFill>
-                        <a:srgbClr val="D9DDD2"/>
-                      </a:solidFill>
-                      <a:prstDash val="solid"/>
-                      <a:round/>
-                      <a:headEnd type="none" w="med" len="med"/>
-                      <a:tailEnd type="none" w="med" len="med"/>
-                    </a:lnT>
-                    <a:lnB w="7620" cap="flat" cmpd="sng" algn="ctr">
-                      <a:solidFill>
-                        <a:srgbClr val="D9DDD2"/>
-                      </a:solidFill>
-                      <a:prstDash val="solid"/>
-                      <a:round/>
-                      <a:headEnd type="none" w="med" len="med"/>
-                      <a:tailEnd type="none" w="med" len="med"/>
-                    </a:lnB>
-                    <a:solidFill>
-                      <a:srgbClr val="F8F7F2"/>
-                    </a:solidFill>
-                  </a:tcPr>
-                </a:tc>
-              </a:tr>
-              <a:tr h="713232">
-                <a:tc>
-                  <a:txBody>
-                    <a:bodyPr/>
-                    <a:lstStyle/>
-                    <a:p>
-                      <a:pPr indent="0" marL="0">
-                        <a:buNone/>
-                      </a:pPr>
-                      <a:r>
-                        <a:rPr lang="en-US" sz="1550" dirty="0">
-                          <a:solidFill>
-                            <a:srgbClr val="34434A"/>
-                          </a:solidFill>
-                          <a:latin typeface="Noto Sans CJK SC" pitchFamily="34" charset="0"/>
-                          <a:ea typeface="Noto Sans CJK SC" pitchFamily="34" charset="-122"/>
-                          <a:cs typeface="Noto Sans CJK SC" pitchFamily="34" charset="-120"/>
-                        </a:rPr>
-                        <a:t>林新淇</a:t>
-                      </a:r>
-                      <a:endParaRPr lang="en-US" sz="1550" dirty="0">
-                        <a:latin typeface="Noto Sans CJK SC" charset="0"/>
-                        <a:ea typeface="Noto Sans CJK SC" charset="0"/>
-                        <a:cs typeface="Noto Sans CJK SC" charset="0"/>
-                      </a:endParaRPr>
-                    </a:p>
-                  </a:txBody>
-                  <a:tcPr marL="127000" marR="127000" marT="88900" marB="88900" anchor="mid">
-                    <a:lnL w="7620" cap="flat" cmpd="sng" algn="ctr">
-                      <a:solidFill>
-                        <a:srgbClr val="D9DDD2"/>
-                      </a:solidFill>
-                      <a:prstDash val="solid"/>
-                      <a:round/>
-                      <a:headEnd type="none" w="med" len="med"/>
-                      <a:tailEnd type="none" w="med" len="med"/>
-                    </a:lnL>
-                    <a:lnR w="7620" cap="flat" cmpd="sng" algn="ctr">
-                      <a:solidFill>
-                        <a:srgbClr val="D9DDD2"/>
-                      </a:solidFill>
-                      <a:prstDash val="solid"/>
-                      <a:round/>
-                      <a:headEnd type="none" w="med" len="med"/>
-                      <a:tailEnd type="none" w="med" len="med"/>
-                    </a:lnR>
-                    <a:lnT w="7620" cap="flat" cmpd="sng" algn="ctr">
-                      <a:solidFill>
-                        <a:srgbClr val="D9DDD2"/>
-                      </a:solidFill>
-                      <a:prstDash val="solid"/>
-                      <a:round/>
-                      <a:headEnd type="none" w="med" len="med"/>
-                      <a:tailEnd type="none" w="med" len="med"/>
-                    </a:lnT>
-                    <a:lnB w="7620" cap="flat" cmpd="sng" algn="ctr">
-                      <a:solidFill>
-                        <a:srgbClr val="D9DDD2"/>
-                      </a:solidFill>
-                      <a:prstDash val="solid"/>
-                      <a:round/>
-                      <a:headEnd type="none" w="med" len="med"/>
-                      <a:tailEnd type="none" w="med" len="med"/>
-                    </a:lnB>
-                    <a:solidFill>
-                      <a:srgbClr val="F8F7F2"/>
-                    </a:solidFill>
-                  </a:tcPr>
-                </a:tc>
-                <a:tc>
-                  <a:txBody>
-                    <a:bodyPr/>
-                    <a:lstStyle/>
-                    <a:p>
-                      <a:pPr indent="0" marL="0">
-                        <a:buNone/>
-                      </a:pPr>
-                      <a:r>
-                        <a:rPr lang="en-US" sz="1550" dirty="0">
-                          <a:solidFill>
-                            <a:srgbClr val="34434A"/>
-                          </a:solidFill>
-                          <a:latin typeface="Noto Sans CJK SC" pitchFamily="34" charset="0"/>
-                          <a:ea typeface="Noto Sans CJK SC" pitchFamily="34" charset="-122"/>
-                          <a:cs typeface="Noto Sans CJK SC" pitchFamily="34" charset="-120"/>
-                        </a:rPr>
-                        <a:t>Design · Materials and construction</a:t>
-                      </a:r>
-                      <a:endParaRPr lang="en-US" sz="1550" dirty="0">
-                        <a:latin typeface="Noto Sans CJK SC" charset="0"/>
-                        <a:ea typeface="Noto Sans CJK SC" charset="0"/>
-                        <a:cs typeface="Noto Sans CJK SC" charset="0"/>
-                      </a:endParaRPr>
-                    </a:p>
-                    <a:p>
-                      <a:pPr indent="0" marL="0">
-                        <a:buNone/>
-                      </a:pPr>
-                      <a:r>
-                        <a:rPr lang="en-US" sz="1550" dirty="0">
-                          <a:solidFill>
-                            <a:srgbClr val="34434A"/>
-                          </a:solidFill>
-                          <a:latin typeface="Noto Sans CJK SC" pitchFamily="34" charset="0"/>
-                          <a:ea typeface="Noto Sans CJK SC" pitchFamily="34" charset="-122"/>
-                          <a:cs typeface="Noto Sans CJK SC" pitchFamily="34" charset="-120"/>
-                        </a:rPr>
-                        <a:t>Material/plant selection; assembly and cost</a:t>
-                      </a:r>
-                      <a:endParaRPr lang="en-US" sz="1550" dirty="0">
-                        <a:latin typeface="Noto Sans CJK SC" charset="0"/>
-                        <a:ea typeface="Noto Sans CJK SC" charset="0"/>
-                        <a:cs typeface="Noto Sans CJK SC" charset="0"/>
-                      </a:endParaRPr>
-                    </a:p>
-                  </a:txBody>
-                  <a:tcPr marL="127000" marR="127000" marT="88900" marB="88900" anchor="mid">
-                    <a:lnL w="7620" cap="flat" cmpd="sng" algn="ctr">
-                      <a:solidFill>
-                        <a:srgbClr val="D9DDD2"/>
-                      </a:solidFill>
-                      <a:prstDash val="solid"/>
-                      <a:round/>
-                      <a:headEnd type="none" w="med" len="med"/>
-                      <a:tailEnd type="none" w="med" len="med"/>
-                    </a:lnL>
-                    <a:lnR w="7620" cap="flat" cmpd="sng" algn="ctr">
-                      <a:solidFill>
-                        <a:srgbClr val="D9DDD2"/>
-                      </a:solidFill>
-                      <a:prstDash val="solid"/>
-                      <a:round/>
-                      <a:headEnd type="none" w="med" len="med"/>
-                      <a:tailEnd type="none" w="med" len="med"/>
-                    </a:lnR>
-                    <a:lnT w="7620" cap="flat" cmpd="sng" algn="ctr">
-                      <a:solidFill>
-                        <a:srgbClr val="D9DDD2"/>
-                      </a:solidFill>
-                      <a:prstDash val="solid"/>
-                      <a:round/>
-                      <a:headEnd type="none" w="med" len="med"/>
-                      <a:tailEnd type="none" w="med" len="med"/>
-                    </a:lnT>
-                    <a:lnB w="7620" cap="flat" cmpd="sng" algn="ctr">
-                      <a:solidFill>
-                        <a:srgbClr val="D9DDD2"/>
-                      </a:solidFill>
-                      <a:prstDash val="solid"/>
-                      <a:round/>
-                      <a:headEnd type="none" w="med" len="med"/>
-                      <a:tailEnd type="none" w="med" len="med"/>
-                    </a:lnB>
-                    <a:solidFill>
-                      <a:srgbClr val="F8F7F2"/>
-                    </a:solidFill>
-                  </a:tcPr>
-                </a:tc>
-                <a:tc>
-                  <a:txBody>
-                    <a:bodyPr/>
-                    <a:lstStyle/>
-                    <a:p>
-                      <a:pPr indent="0" marL="0">
-                        <a:buNone/>
-                      </a:pPr>
-                      <a:r>
-                        <a:rPr lang="en-US" sz="1550" dirty="0">
-                          <a:solidFill>
-                            <a:srgbClr val="34434A"/>
-                          </a:solidFill>
-                          <a:latin typeface="Noto Sans CJK SC" pitchFamily="34" charset="0"/>
-                          <a:ea typeface="Noto Sans CJK SC" pitchFamily="34" charset="-122"/>
-                          <a:cs typeface="Noto Sans CJK SC" pitchFamily="34" charset="-120"/>
-                        </a:rPr>
-                        <a:t>Material rationale; build-up and cost estimate</a:t>
-                      </a:r>
-                      <a:endParaRPr lang="en-US" sz="1550" dirty="0">
-                        <a:latin typeface="Noto Sans CJK SC" charset="0"/>
-                        <a:ea typeface="Noto Sans CJK SC" charset="0"/>
-                        <a:cs typeface="Noto Sans CJK SC" charset="0"/>
-                      </a:endParaRPr>
-                    </a:p>
-                  </a:txBody>
-                  <a:tcPr marL="127000" marR="127000" marT="88900" marB="88900" anchor="mid">
-                    <a:lnL w="7620" cap="flat" cmpd="sng" algn="ctr">
-                      <a:solidFill>
-                        <a:srgbClr val="D9DDD2"/>
-                      </a:solidFill>
-                      <a:prstDash val="solid"/>
-                      <a:round/>
-                      <a:headEnd type="none" w="med" len="med"/>
-                      <a:tailEnd type="none" w="med" len="med"/>
-                    </a:lnL>
-                    <a:lnR w="7620" cap="flat" cmpd="sng" algn="ctr">
-                      <a:solidFill>
-                        <a:srgbClr val="D9DDD2"/>
-                      </a:solidFill>
-                      <a:prstDash val="solid"/>
-                      <a:round/>
-                      <a:headEnd type="none" w="med" len="med"/>
-                      <a:tailEnd type="none" w="med" len="med"/>
-                    </a:lnR>
-                    <a:lnT w="7620" cap="flat" cmpd="sng" algn="ctr">
-                      <a:solidFill>
-                        <a:srgbClr val="D9DDD2"/>
-                      </a:solidFill>
-                      <a:prstDash val="solid"/>
-                      <a:round/>
-                      <a:headEnd type="none" w="med" len="med"/>
-                      <a:tailEnd type="none" w="med" len="med"/>
-                    </a:lnT>
-                    <a:lnB w="7620" cap="flat" cmpd="sng" algn="ctr">
-                      <a:solidFill>
-                        <a:srgbClr val="D9DDD2"/>
-                      </a:solidFill>
-                      <a:prstDash val="solid"/>
-                      <a:round/>
-                      <a:headEnd type="none" w="med" len="med"/>
-                      <a:tailEnd type="none" w="med" len="med"/>
-                    </a:lnB>
-                    <a:solidFill>
-                      <a:srgbClr val="F8F7F2"/>
-                    </a:solidFill>
-                  </a:tcPr>
-                </a:tc>
-              </a:tr>
-              <a:tr h="713232">
-                <a:tc>
-                  <a:txBody>
-                    <a:bodyPr/>
-                    <a:lstStyle/>
-                    <a:p>
-                      <a:pPr indent="0" marL="0">
-                        <a:buNone/>
-                      </a:pPr>
-                      <a:r>
-                        <a:rPr lang="en-US" sz="1550" dirty="0">
-                          <a:solidFill>
-                            <a:srgbClr val="34434A"/>
-                          </a:solidFill>
-                          <a:latin typeface="Noto Sans CJK SC" pitchFamily="34" charset="0"/>
-                          <a:ea typeface="Noto Sans CJK SC" pitchFamily="34" charset="-122"/>
-                          <a:cs typeface="Noto Sans CJK SC" pitchFamily="34" charset="-120"/>
-                        </a:rPr>
-                        <a:t>虞寒哲</a:t>
-                      </a:r>
-                      <a:endParaRPr lang="en-US" sz="1550" dirty="0">
-                        <a:latin typeface="Noto Sans CJK SC" charset="0"/>
-                        <a:ea typeface="Noto Sans CJK SC" charset="0"/>
-                        <a:cs typeface="Noto Sans CJK SC" charset="0"/>
-                      </a:endParaRPr>
-                    </a:p>
-                  </a:txBody>
-                  <a:tcPr marL="127000" marR="127000" marT="88900" marB="88900" anchor="mid">
-                    <a:lnL w="7620" cap="flat" cmpd="sng" algn="ctr">
-                      <a:solidFill>
-                        <a:srgbClr val="D9DDD2"/>
-                      </a:solidFill>
-                      <a:prstDash val="solid"/>
-                      <a:round/>
-                      <a:headEnd type="none" w="med" len="med"/>
-                      <a:tailEnd type="none" w="med" len="med"/>
-                    </a:lnL>
-                    <a:lnR w="7620" cap="flat" cmpd="sng" algn="ctr">
-                      <a:solidFill>
-                        <a:srgbClr val="D9DDD2"/>
-                      </a:solidFill>
-                      <a:prstDash val="solid"/>
-                      <a:round/>
-                      <a:headEnd type="none" w="med" len="med"/>
-                      <a:tailEnd type="none" w="med" len="med"/>
-                    </a:lnR>
-                    <a:lnT w="7620" cap="flat" cmpd="sng" algn="ctr">
-                      <a:solidFill>
-                        <a:srgbClr val="D9DDD2"/>
-                      </a:solidFill>
-                      <a:prstDash val="solid"/>
-                      <a:round/>
-                      <a:headEnd type="none" w="med" len="med"/>
-                      <a:tailEnd type="none" w="med" len="med"/>
-                    </a:lnT>
-                    <a:lnB w="7620" cap="flat" cmpd="sng" algn="ctr">
-                      <a:solidFill>
-                        <a:srgbClr val="D9DDD2"/>
-                      </a:solidFill>
-                      <a:prstDash val="solid"/>
-                      <a:round/>
-                      <a:headEnd type="none" w="med" len="med"/>
-                      <a:tailEnd type="none" w="med" len="med"/>
-                    </a:lnB>
-                    <a:solidFill>
-                      <a:srgbClr val="F8F7F2"/>
-                    </a:solidFill>
-                  </a:tcPr>
-                </a:tc>
-                <a:tc>
-                  <a:txBody>
-                    <a:bodyPr/>
-                    <a:lstStyle/>
-                    <a:p>
-                      <a:pPr indent="0" marL="0">
-                        <a:buNone/>
-                      </a:pPr>
-                      <a:r>
-                        <a:rPr lang="en-US" sz="1550" dirty="0">
-                          <a:solidFill>
-                            <a:srgbClr val="34434A"/>
-                          </a:solidFill>
-                          <a:latin typeface="Noto Sans CJK SC" pitchFamily="34" charset="0"/>
-                          <a:ea typeface="Noto Sans CJK SC" pitchFamily="34" charset="-122"/>
-                          <a:cs typeface="Noto Sans CJK SC" pitchFamily="34" charset="-120"/>
-                        </a:rPr>
-                        <a:t>Design · Shade and application</a:t>
-                      </a:r>
-                      <a:endParaRPr lang="en-US" sz="1550" dirty="0">
-                        <a:latin typeface="Noto Sans CJK SC" charset="0"/>
-                        <a:ea typeface="Noto Sans CJK SC" charset="0"/>
-                        <a:cs typeface="Noto Sans CJK SC" charset="0"/>
-                      </a:endParaRPr>
-                    </a:p>
-                    <a:p>
-                      <a:pPr indent="0" marL="0">
-                        <a:buNone/>
-                      </a:pPr>
-                      <a:r>
-                        <a:rPr lang="en-US" sz="1550" dirty="0">
-                          <a:solidFill>
-                            <a:srgbClr val="34434A"/>
-                          </a:solidFill>
-                          <a:latin typeface="Noto Sans CJK SC" pitchFamily="34" charset="0"/>
-                          <a:ea typeface="Noto Sans CJK SC" pitchFamily="34" charset="-122"/>
-                          <a:cs typeface="Noto Sans CJK SC" pitchFamily="34" charset="-120"/>
-                        </a:rPr>
-                        <a:t>Canopy analysis; comfort mechanisms and use</a:t>
-                      </a:r>
-                      <a:endParaRPr lang="en-US" sz="1550" dirty="0">
-                        <a:latin typeface="Noto Sans CJK SC" charset="0"/>
-                        <a:ea typeface="Noto Sans CJK SC" charset="0"/>
-                        <a:cs typeface="Noto Sans CJK SC" charset="0"/>
-                      </a:endParaRPr>
-                    </a:p>
-                  </a:txBody>
-                  <a:tcPr marL="127000" marR="127000" marT="88900" marB="88900" anchor="mid">
-                    <a:lnL w="7620" cap="flat" cmpd="sng" algn="ctr">
-                      <a:solidFill>
-                        <a:srgbClr val="D9DDD2"/>
-                      </a:solidFill>
-                      <a:prstDash val="solid"/>
-                      <a:round/>
-                      <a:headEnd type="none" w="med" len="med"/>
-                      <a:tailEnd type="none" w="med" len="med"/>
-                    </a:lnL>
-                    <a:lnR w="7620" cap="flat" cmpd="sng" algn="ctr">
-                      <a:solidFill>
-                        <a:srgbClr val="D9DDD2"/>
-                      </a:solidFill>
-                      <a:prstDash val="solid"/>
-                      <a:round/>
-                      <a:headEnd type="none" w="med" len="med"/>
-                      <a:tailEnd type="none" w="med" len="med"/>
-                    </a:lnR>
-                    <a:lnT w="7620" cap="flat" cmpd="sng" algn="ctr">
-                      <a:solidFill>
-                        <a:srgbClr val="D9DDD2"/>
-                      </a:solidFill>
-                      <a:prstDash val="solid"/>
-                      <a:round/>
-                      <a:headEnd type="none" w="med" len="med"/>
-                      <a:tailEnd type="none" w="med" len="med"/>
-                    </a:lnT>
-                    <a:lnB w="7620" cap="flat" cmpd="sng" algn="ctr">
-                      <a:solidFill>
-                        <a:srgbClr val="D9DDD2"/>
-                      </a:solidFill>
-                      <a:prstDash val="solid"/>
-                      <a:round/>
-                      <a:headEnd type="none" w="med" len="med"/>
-                      <a:tailEnd type="none" w="med" len="med"/>
-                    </a:lnB>
-                    <a:solidFill>
-                      <a:srgbClr val="F8F7F2"/>
-                    </a:solidFill>
-                  </a:tcPr>
-                </a:tc>
-                <a:tc>
-                  <a:txBody>
-                    <a:bodyPr/>
-                    <a:lstStyle/>
-                    <a:p>
-                      <a:pPr indent="0" marL="0">
-                        <a:buNone/>
-                      </a:pPr>
-                      <a:r>
-                        <a:rPr lang="en-US" sz="1550" dirty="0">
-                          <a:solidFill>
-                            <a:srgbClr val="34434A"/>
-                          </a:solidFill>
-                          <a:latin typeface="Noto Sans CJK SC" pitchFamily="34" charset="0"/>
-                          <a:ea typeface="Noto Sans CJK SC" pitchFamily="34" charset="-122"/>
-                          <a:cs typeface="Noto Sans CJK SC" pitchFamily="34" charset="-120"/>
-                        </a:rPr>
-                        <a:t>Shade analysis; application and design statement</a:t>
-                      </a:r>
-                      <a:endParaRPr lang="en-US" sz="1550" dirty="0">
-                        <a:latin typeface="Noto Sans CJK SC" charset="0"/>
-                        <a:ea typeface="Noto Sans CJK SC" charset="0"/>
-                        <a:cs typeface="Noto Sans CJK SC" charset="0"/>
-                      </a:endParaRPr>
-                    </a:p>
-                  </a:txBody>
-                  <a:tcPr marL="127000" marR="127000" marT="88900" marB="88900" anchor="mid">
-                    <a:lnL w="7620" cap="flat" cmpd="sng" algn="ctr">
-                      <a:solidFill>
-                        <a:srgbClr val="D9DDD2"/>
-                      </a:solidFill>
-                      <a:prstDash val="solid"/>
-                      <a:round/>
-                      <a:headEnd type="none" w="med" len="med"/>
-                      <a:tailEnd type="none" w="med" len="med"/>
-                    </a:lnL>
-                    <a:lnR w="7620" cap="flat" cmpd="sng" algn="ctr">
-                      <a:solidFill>
-                        <a:srgbClr val="D9DDD2"/>
-                      </a:solidFill>
-                      <a:prstDash val="solid"/>
-                      <a:round/>
-                      <a:headEnd type="none" w="med" len="med"/>
-                      <a:tailEnd type="none" w="med" len="med"/>
-                    </a:lnR>
-                    <a:lnT w="7620" cap="flat" cmpd="sng" algn="ctr">
-                      <a:solidFill>
-                        <a:srgbClr val="D9DDD2"/>
-                      </a:solidFill>
-                      <a:prstDash val="solid"/>
-                      <a:round/>
-                      <a:headEnd type="none" w="med" len="med"/>
-                      <a:tailEnd type="none" w="med" len="med"/>
-                    </a:lnT>
-                    <a:lnB w="7620" cap="flat" cmpd="sng" algn="ctr">
-                      <a:solidFill>
-                        <a:srgbClr val="D9DDD2"/>
-                      </a:solidFill>
-                      <a:prstDash val="solid"/>
-                      <a:round/>
-                      <a:headEnd type="none" w="med" len="med"/>
-                      <a:tailEnd type="none" w="med" len="med"/>
-                    </a:lnB>
-                    <a:solidFill>
-                      <a:srgbClr val="F8F7F2"/>
-                    </a:solidFill>
-                  </a:tcPr>
-                </a:tc>
-              </a:tr>
-              <a:tr h="713232">
-                <a:tc>
-                  <a:txBody>
-                    <a:bodyPr/>
-                    <a:lstStyle/>
-                    <a:p>
-                      <a:pPr indent="0" marL="0">
-                        <a:buNone/>
-                      </a:pPr>
-                      <a:r>
-                        <a:rPr lang="en-US" sz="1550" dirty="0">
-                          <a:solidFill>
-                            <a:srgbClr val="34434A"/>
-                          </a:solidFill>
-                          <a:latin typeface="Noto Sans CJK SC" pitchFamily="34" charset="0"/>
-                          <a:ea typeface="Noto Sans CJK SC" pitchFamily="34" charset="-122"/>
-                          <a:cs typeface="Noto Sans CJK SC" pitchFamily="34" charset="-120"/>
-                        </a:rPr>
-                        <a:t>徐世程</a:t>
-                      </a:r>
-                      <a:endParaRPr lang="en-US" sz="1550" dirty="0">
-                        <a:latin typeface="Noto Sans CJK SC" charset="0"/>
-                        <a:ea typeface="Noto Sans CJK SC" charset="0"/>
-                        <a:cs typeface="Noto Sans CJK SC" charset="0"/>
-                      </a:endParaRPr>
-                    </a:p>
-                  </a:txBody>
-                  <a:tcPr marL="127000" marR="127000" marT="88900" marB="88900" anchor="mid">
-                    <a:lnL w="7620" cap="flat" cmpd="sng" algn="ctr">
-                      <a:solidFill>
-                        <a:srgbClr val="D9DDD2"/>
-                      </a:solidFill>
-                      <a:prstDash val="solid"/>
-                      <a:round/>
-                      <a:headEnd type="none" w="med" len="med"/>
-                      <a:tailEnd type="none" w="med" len="med"/>
-                    </a:lnL>
-                    <a:lnR w="7620" cap="flat" cmpd="sng" algn="ctr">
-                      <a:solidFill>
-                        <a:srgbClr val="D9DDD2"/>
-                      </a:solidFill>
-                      <a:prstDash val="solid"/>
-                      <a:round/>
-                      <a:headEnd type="none" w="med" len="med"/>
-                      <a:tailEnd type="none" w="med" len="med"/>
-                    </a:lnR>
-                    <a:lnT w="7620" cap="flat" cmpd="sng" algn="ctr">
-                      <a:solidFill>
-                        <a:srgbClr val="D9DDD2"/>
-                      </a:solidFill>
-                      <a:prstDash val="solid"/>
-                      <a:round/>
-                      <a:headEnd type="none" w="med" len="med"/>
-                      <a:tailEnd type="none" w="med" len="med"/>
-                    </a:lnT>
-                    <a:lnB w="7620" cap="flat" cmpd="sng" algn="ctr">
-                      <a:solidFill>
-                        <a:srgbClr val="D9DDD2"/>
-                      </a:solidFill>
-                      <a:prstDash val="solid"/>
-                      <a:round/>
-                      <a:headEnd type="none" w="med" len="med"/>
-                      <a:tailEnd type="none" w="med" len="med"/>
-                    </a:lnB>
-                    <a:solidFill>
-                      <a:srgbClr val="F8F7F2"/>
-                    </a:solidFill>
-                  </a:tcPr>
-                </a:tc>
-                <a:tc>
-                  <a:txBody>
-                    <a:bodyPr/>
-                    <a:lstStyle/>
-                    <a:p>
-                      <a:pPr indent="0" marL="0">
-                        <a:buNone/>
-                      </a:pPr>
-                      <a:r>
-                        <a:rPr lang="en-US" sz="1550" dirty="0">
-                          <a:solidFill>
-                            <a:srgbClr val="34434A"/>
-                          </a:solidFill>
-                          <a:latin typeface="Noto Sans CJK SC" pitchFamily="34" charset="0"/>
-                          <a:ea typeface="Noto Sans CJK SC" pitchFamily="34" charset="-122"/>
-                          <a:cs typeface="Noto Sans CJK SC" pitchFamily="34" charset="-120"/>
-                        </a:rPr>
-                        <a:t>PPT · Production and integration</a:t>
-                      </a:r>
-                      <a:endParaRPr lang="en-US" sz="1550" dirty="0">
-                        <a:latin typeface="Noto Sans CJK SC" charset="0"/>
-                        <a:ea typeface="Noto Sans CJK SC" charset="0"/>
-                        <a:cs typeface="Noto Sans CJK SC" charset="0"/>
-                      </a:endParaRPr>
-                    </a:p>
-                    <a:p>
-                      <a:pPr indent="0" marL="0">
-                        <a:buNone/>
-                      </a:pPr>
-                      <a:r>
-                        <a:rPr lang="en-US" sz="1550" dirty="0">
-                          <a:solidFill>
-                            <a:srgbClr val="34434A"/>
-                          </a:solidFill>
-                          <a:latin typeface="Noto Sans CJK SC" pitchFamily="34" charset="0"/>
-                          <a:ea typeface="Noto Sans CJK SC" pitchFamily="34" charset="-122"/>
-                          <a:cs typeface="Noto Sans CJK SC" pitchFamily="34" charset="-120"/>
-                        </a:rPr>
-                        <a:t>Structure, charts, layout and visual consistency</a:t>
-                      </a:r>
-                      <a:endParaRPr lang="en-US" sz="1550" dirty="0">
-                        <a:latin typeface="Noto Sans CJK SC" charset="0"/>
-                        <a:ea typeface="Noto Sans CJK SC" charset="0"/>
-                        <a:cs typeface="Noto Sans CJK SC" charset="0"/>
-                      </a:endParaRPr>
-                    </a:p>
-                  </a:txBody>
-                  <a:tcPr marL="127000" marR="127000" marT="88900" marB="88900" anchor="mid">
-                    <a:lnL w="7620" cap="flat" cmpd="sng" algn="ctr">
-                      <a:solidFill>
-                        <a:srgbClr val="D9DDD2"/>
-                      </a:solidFill>
-                      <a:prstDash val="solid"/>
-                      <a:round/>
-                      <a:headEnd type="none" w="med" len="med"/>
-                      <a:tailEnd type="none" w="med" len="med"/>
-                    </a:lnL>
-                    <a:lnR w="7620" cap="flat" cmpd="sng" algn="ctr">
-                      <a:solidFill>
-                        <a:srgbClr val="D9DDD2"/>
-                      </a:solidFill>
-                      <a:prstDash val="solid"/>
-                      <a:round/>
-                      <a:headEnd type="none" w="med" len="med"/>
-                      <a:tailEnd type="none" w="med" len="med"/>
-                    </a:lnR>
-                    <a:lnT w="7620" cap="flat" cmpd="sng" algn="ctr">
-                      <a:solidFill>
-                        <a:srgbClr val="D9DDD2"/>
-                      </a:solidFill>
-                      <a:prstDash val="solid"/>
-                      <a:round/>
-                      <a:headEnd type="none" w="med" len="med"/>
-                      <a:tailEnd type="none" w="med" len="med"/>
-                    </a:lnT>
-                    <a:lnB w="7620" cap="flat" cmpd="sng" algn="ctr">
-                      <a:solidFill>
-                        <a:srgbClr val="D9DDD2"/>
-                      </a:solidFill>
-                      <a:prstDash val="solid"/>
-                      <a:round/>
-                      <a:headEnd type="none" w="med" len="med"/>
-                      <a:tailEnd type="none" w="med" len="med"/>
-                    </a:lnB>
-                    <a:solidFill>
-                      <a:srgbClr val="F8F7F2"/>
-                    </a:solidFill>
-                  </a:tcPr>
-                </a:tc>
-                <a:tc>
-                  <a:txBody>
-                    <a:bodyPr/>
-                    <a:lstStyle/>
-                    <a:p>
-                      <a:pPr indent="0" marL="0">
-                        <a:buNone/>
-                      </a:pPr>
-                      <a:r>
-                        <a:rPr lang="en-US" sz="1550" dirty="0">
-                          <a:solidFill>
-                            <a:srgbClr val="34434A"/>
-                          </a:solidFill>
-                          <a:latin typeface="Noto Sans CJK SC" pitchFamily="34" charset="0"/>
-                          <a:ea typeface="Noto Sans CJK SC" pitchFamily="34" charset="-122"/>
-                          <a:cs typeface="Noto Sans CJK SC" pitchFamily="34" charset="-120"/>
-                        </a:rPr>
-                        <a:t>Integrated presentation within 20 slides</a:t>
-                      </a:r>
-                      <a:endParaRPr lang="en-US" sz="1550" dirty="0">
-                        <a:latin typeface="Noto Sans CJK SC" charset="0"/>
-                        <a:ea typeface="Noto Sans CJK SC" charset="0"/>
-                        <a:cs typeface="Noto Sans CJK SC" charset="0"/>
-                      </a:endParaRPr>
-                    </a:p>
-                  </a:txBody>
-                  <a:tcPr marL="127000" marR="127000" marT="88900" marB="88900" anchor="mid">
-                    <a:lnL w="7620" cap="flat" cmpd="sng" algn="ctr">
-                      <a:solidFill>
-                        <a:srgbClr val="D9DDD2"/>
-                      </a:solidFill>
-                      <a:prstDash val="solid"/>
-                      <a:round/>
-                      <a:headEnd type="none" w="med" len="med"/>
-                      <a:tailEnd type="none" w="med" len="med"/>
-                    </a:lnL>
-                    <a:lnR w="7620" cap="flat" cmpd="sng" algn="ctr">
-                      <a:solidFill>
-                        <a:srgbClr val="D9DDD2"/>
-                      </a:solidFill>
-                      <a:prstDash val="solid"/>
-                      <a:round/>
-                      <a:headEnd type="none" w="med" len="med"/>
-                      <a:tailEnd type="none" w="med" len="med"/>
-                    </a:lnR>
-                    <a:lnT w="7620" cap="flat" cmpd="sng" algn="ctr">
-                      <a:solidFill>
-                        <a:srgbClr val="D9DDD2"/>
-                      </a:solidFill>
-                      <a:prstDash val="solid"/>
-                      <a:round/>
-                      <a:headEnd type="none" w="med" len="med"/>
-                      <a:tailEnd type="none" w="med" len="med"/>
-                    </a:lnT>
-                    <a:lnB w="7620" cap="flat" cmpd="sng" algn="ctr">
-                      <a:solidFill>
-                        <a:srgbClr val="D9DDD2"/>
-                      </a:solidFill>
-                      <a:prstDash val="solid"/>
-                      <a:round/>
-                      <a:headEnd type="none" w="med" len="med"/>
-                      <a:tailEnd type="none" w="med" len="med"/>
-                    </a:lnB>
-                    <a:solidFill>
-                      <a:srgbClr val="F8F7F2"/>
-                    </a:solidFill>
-                  </a:tcPr>
-                </a:tc>
-              </a:tr>
-              <a:tr h="713232">
-                <a:tc>
-                  <a:txBody>
-                    <a:bodyPr/>
-                    <a:lstStyle/>
-                    <a:p>
-                      <a:pPr indent="0" marL="0">
-                        <a:buNone/>
-                      </a:pPr>
-                      <a:r>
-                        <a:rPr lang="en-US" sz="1550" dirty="0">
-                          <a:solidFill>
-                            <a:srgbClr val="34434A"/>
-                          </a:solidFill>
-                          <a:latin typeface="Noto Sans CJK SC" pitchFamily="34" charset="0"/>
-                          <a:ea typeface="Noto Sans CJK SC" pitchFamily="34" charset="-122"/>
-                          <a:cs typeface="Noto Sans CJK SC" pitchFamily="34" charset="-120"/>
-                        </a:rPr>
-                        <a:t>陈淼</a:t>
-                      </a:r>
-                      <a:endParaRPr lang="en-US" sz="1550" dirty="0">
-                        <a:latin typeface="Noto Sans CJK SC" charset="0"/>
-                        <a:ea typeface="Noto Sans CJK SC" charset="0"/>
-                        <a:cs typeface="Noto Sans CJK SC" charset="0"/>
-                      </a:endParaRPr>
-                    </a:p>
-                  </a:txBody>
-                  <a:tcPr marL="127000" marR="127000" marT="88900" marB="88900" anchor="mid">
-                    <a:lnL w="7620" cap="flat" cmpd="sng" algn="ctr">
-                      <a:solidFill>
-                        <a:srgbClr val="D9DDD2"/>
-                      </a:solidFill>
-                      <a:prstDash val="solid"/>
-                      <a:round/>
-                      <a:headEnd type="none" w="med" len="med"/>
-                      <a:tailEnd type="none" w="med" len="med"/>
-                    </a:lnL>
-                    <a:lnR w="7620" cap="flat" cmpd="sng" algn="ctr">
-                      <a:solidFill>
-                        <a:srgbClr val="D9DDD2"/>
-                      </a:solidFill>
-                      <a:prstDash val="solid"/>
-                      <a:round/>
-                      <a:headEnd type="none" w="med" len="med"/>
-                      <a:tailEnd type="none" w="med" len="med"/>
-                    </a:lnR>
-                    <a:lnT w="7620" cap="flat" cmpd="sng" algn="ctr">
-                      <a:solidFill>
-                        <a:srgbClr val="D9DDD2"/>
-                      </a:solidFill>
-                      <a:prstDash val="solid"/>
-                      <a:round/>
-                      <a:headEnd type="none" w="med" len="med"/>
-                      <a:tailEnd type="none" w="med" len="med"/>
-                    </a:lnT>
-                    <a:lnB w="7620" cap="flat" cmpd="sng" algn="ctr">
-                      <a:solidFill>
-                        <a:srgbClr val="D9DDD2"/>
-                      </a:solidFill>
-                      <a:prstDash val="solid"/>
-                      <a:round/>
-                      <a:headEnd type="none" w="med" len="med"/>
-                      <a:tailEnd type="none" w="med" len="med"/>
-                    </a:lnB>
-                    <a:solidFill>
-                      <a:srgbClr val="F8F7F2"/>
-                    </a:solidFill>
-                  </a:tcPr>
-                </a:tc>
-                <a:tc>
-                  <a:txBody>
-                    <a:bodyPr/>
-                    <a:lstStyle/>
-                    <a:p>
-                      <a:pPr indent="0" marL="0">
-                        <a:buNone/>
-                      </a:pPr>
-                      <a:r>
-                        <a:rPr lang="en-US" sz="1550" dirty="0">
-                          <a:solidFill>
-                            <a:srgbClr val="34434A"/>
-                          </a:solidFill>
-                          <a:latin typeface="Noto Sans CJK SC" pitchFamily="34" charset="0"/>
-                          <a:ea typeface="Noto Sans CJK SC" pitchFamily="34" charset="-122"/>
-                          <a:cs typeface="Noto Sans CJK SC" pitchFamily="34" charset="-120"/>
-                        </a:rPr>
-                        <a:t>Presentation · Script and delivery</a:t>
-                      </a:r>
-                      <a:endParaRPr lang="en-US" sz="1550" dirty="0">
-                        <a:latin typeface="Noto Sans CJK SC" charset="0"/>
-                        <a:ea typeface="Noto Sans CJK SC" charset="0"/>
-                        <a:cs typeface="Noto Sans CJK SC" charset="0"/>
-                      </a:endParaRPr>
-                    </a:p>
-                    <a:p>
-                      <a:pPr indent="0" marL="0">
-                        <a:buNone/>
-                      </a:pPr>
-                      <a:r>
-                        <a:rPr lang="en-US" sz="1550" dirty="0">
-                          <a:solidFill>
-                            <a:srgbClr val="34434A"/>
-                          </a:solidFill>
-                          <a:latin typeface="Noto Sans CJK SC" pitchFamily="34" charset="0"/>
-                          <a:ea typeface="Noto Sans CJK SC" pitchFamily="34" charset="-122"/>
-                          <a:cs typeface="Noto Sans CJK SC" pitchFamily="34" charset="-120"/>
-                        </a:rPr>
-                        <a:t>English presentation, timing and Q&amp;A</a:t>
-                      </a:r>
-                      <a:endParaRPr lang="en-US" sz="1550" dirty="0">
-                        <a:latin typeface="Noto Sans CJK SC" charset="0"/>
-                        <a:ea typeface="Noto Sans CJK SC" charset="0"/>
-                        <a:cs typeface="Noto Sans CJK SC" charset="0"/>
-                      </a:endParaRPr>
-                    </a:p>
-                  </a:txBody>
-                  <a:tcPr marL="127000" marR="127000" marT="88900" marB="88900" anchor="mid">
-                    <a:lnL w="7620" cap="flat" cmpd="sng" algn="ctr">
-                      <a:solidFill>
-                        <a:srgbClr val="D9DDD2"/>
-                      </a:solidFill>
-                      <a:prstDash val="solid"/>
-                      <a:round/>
-                      <a:headEnd type="none" w="med" len="med"/>
-                      <a:tailEnd type="none" w="med" len="med"/>
-                    </a:lnL>
-                    <a:lnR w="7620" cap="flat" cmpd="sng" algn="ctr">
-                      <a:solidFill>
-                        <a:srgbClr val="D9DDD2"/>
-                      </a:solidFill>
-                      <a:prstDash val="solid"/>
-                      <a:round/>
-                      <a:headEnd type="none" w="med" len="med"/>
-                      <a:tailEnd type="none" w="med" len="med"/>
-                    </a:lnR>
-                    <a:lnT w="7620" cap="flat" cmpd="sng" algn="ctr">
-                      <a:solidFill>
-                        <a:srgbClr val="D9DDD2"/>
-                      </a:solidFill>
-                      <a:prstDash val="solid"/>
-                      <a:round/>
-                      <a:headEnd type="none" w="med" len="med"/>
-                      <a:tailEnd type="none" w="med" len="med"/>
-                    </a:lnT>
-                    <a:lnB w="7620" cap="flat" cmpd="sng" algn="ctr">
-                      <a:solidFill>
-                        <a:srgbClr val="D9DDD2"/>
-                      </a:solidFill>
-                      <a:prstDash val="solid"/>
-                      <a:round/>
-                      <a:headEnd type="none" w="med" len="med"/>
-                      <a:tailEnd type="none" w="med" len="med"/>
-                    </a:lnB>
-                    <a:solidFill>
-                      <a:srgbClr val="F8F7F2"/>
-                    </a:solidFill>
-                  </a:tcPr>
-                </a:tc>
-                <a:tc>
-                  <a:txBody>
-                    <a:bodyPr/>
-                    <a:lstStyle/>
-                    <a:p>
-                      <a:pPr indent="0" marL="0">
-                        <a:buNone/>
-                      </a:pPr>
-                      <a:r>
-                        <a:rPr lang="en-US" sz="1550" dirty="0">
-                          <a:solidFill>
-                            <a:srgbClr val="34434A"/>
-                          </a:solidFill>
-                          <a:latin typeface="Noto Sans CJK SC" pitchFamily="34" charset="0"/>
-                          <a:ea typeface="Noto Sans CJK SC" pitchFamily="34" charset="-122"/>
-                          <a:cs typeface="Noto Sans CJK SC" pitchFamily="34" charset="-120"/>
-                        </a:rPr>
-                        <a:t>Presentation script and live delivery</a:t>
-                      </a:r>
-                      <a:endParaRPr lang="en-US" sz="1550" dirty="0">
-                        <a:latin typeface="Noto Sans CJK SC" charset="0"/>
-                        <a:ea typeface="Noto Sans CJK SC" charset="0"/>
-                        <a:cs typeface="Noto Sans CJK SC" charset="0"/>
-                      </a:endParaRPr>
-                    </a:p>
-                  </a:txBody>
-                  <a:tcPr marL="127000" marR="127000" marT="88900" marB="88900" anchor="mid">
-                    <a:lnL w="7620" cap="flat" cmpd="sng" algn="ctr">
-                      <a:solidFill>
-                        <a:srgbClr val="D9DDD2"/>
-                      </a:solidFill>
-                      <a:prstDash val="solid"/>
-                      <a:round/>
-                      <a:headEnd type="none" w="med" len="med"/>
-                      <a:tailEnd type="none" w="med" len="med"/>
-                    </a:lnL>
-                    <a:lnR w="7620" cap="flat" cmpd="sng" algn="ctr">
-                      <a:solidFill>
-                        <a:srgbClr val="D9DDD2"/>
-                      </a:solidFill>
-                      <a:prstDash val="solid"/>
-                      <a:round/>
-                      <a:headEnd type="none" w="med" len="med"/>
-                      <a:tailEnd type="none" w="med" len="med"/>
-                    </a:lnR>
-                    <a:lnT w="7620" cap="flat" cmpd="sng" algn="ctr">
-                      <a:solidFill>
-                        <a:srgbClr val="D9DDD2"/>
-                      </a:solidFill>
-                      <a:prstDash val="solid"/>
-                      <a:round/>
-                      <a:headEnd type="none" w="med" len="med"/>
-                      <a:tailEnd type="none" w="med" len="med"/>
-                    </a:lnT>
-                    <a:lnB w="7620" cap="flat" cmpd="sng" algn="ctr">
-                      <a:solidFill>
-                        <a:srgbClr val="D9DDD2"/>
-                      </a:solidFill>
-                      <a:prstDash val="solid"/>
-                      <a:round/>
-                      <a:headEnd type="none" w="med" len="med"/>
-                      <a:tailEnd type="none" w="med" len="med"/>
-                    </a:lnB>
-                    <a:solidFill>
-                      <a:srgbClr val="F8F7F2"/>
-                    </a:solidFill>
-                  </a:tcPr>
-                </a:tc>
-              </a:tr>
-            </a:tbl>
-          </a:graphicData>
-        </a:graphic>
-      </p:graphicFrame>
+                <a:latin typeface="Noto Sans CJK SC" pitchFamily="34" charset="0"/>
+                <a:ea typeface="Noto Sans CJK SC" pitchFamily="34" charset="-122"/>
+                <a:cs typeface="Noto Sans CJK SC" pitchFamily="34" charset="-120"/>
+              </a:rPr>
+              <a:t>臧唯羽</a:t>
+            </a:r>
+            <a:endParaRPr lang="en-US" sz="1700" dirty="0"/>
+          </a:p>
+        </p:txBody>
+      </p:sp>
+      <p:sp>
+        <p:nvSpPr>
+          <p:cNvPr id="17" name="Text 14"/>
+          <p:cNvSpPr/>
+          <p:nvPr/>
+        </p:nvSpPr>
+        <p:spPr>
+          <a:xfrm>
+            <a:off x="685800" y="6089904"/>
+            <a:ext cx="2048256" cy="429768"/>
+          </a:xfrm>
+          <a:prstGeom prst="rect">
+            <a:avLst/>
+          </a:prstGeom>
+          <a:noFill/>
+          <a:ln/>
+        </p:spPr>
+        <p:txBody>
+          <a:bodyPr wrap="square" lIns="0" tIns="0" rIns="0" bIns="0" rtlCol="0" anchor="ctr"/>
+          <a:lstStyle/>
+          <a:p>
+            <a:pPr indent="0" marL="0">
+              <a:buNone/>
+            </a:pPr>
+            <a:r>
+              <a:rPr lang="en-US" sz="1250" dirty="0">
+                <a:solidFill>
+                  <a:srgbClr val="66736D"/>
+                </a:solidFill>
+                <a:latin typeface="Noto Sans" pitchFamily="34" charset="0"/>
+                <a:ea typeface="Noto Sans" pitchFamily="34" charset="-122"/>
+                <a:cs typeface="Noto Sans" pitchFamily="34" charset="-120"/>
+              </a:rPr>
+              <a:t>Form &amp; parametric</a:t>
+            </a:r>
+            <a:endParaRPr lang="en-US" sz="1250" dirty="0"/>
+          </a:p>
+          <a:p>
+            <a:pPr indent="0" marL="0">
+              <a:buNone/>
+            </a:pPr>
+            <a:r>
+              <a:rPr lang="en-US" sz="1250" dirty="0">
+                <a:solidFill>
+                  <a:srgbClr val="66736D"/>
+                </a:solidFill>
+                <a:latin typeface="Noto Sans" pitchFamily="34" charset="0"/>
+                <a:ea typeface="Noto Sans" pitchFamily="34" charset="-122"/>
+                <a:cs typeface="Noto Sans" pitchFamily="34" charset="-120"/>
+              </a:rPr>
+              <a:t>modelling</a:t>
+            </a:r>
+            <a:endParaRPr lang="en-US" sz="1250" dirty="0"/>
+          </a:p>
+        </p:txBody>
+      </p:sp>
+      <p:sp>
+        <p:nvSpPr>
+          <p:cNvPr id="18" name="Text 15"/>
+          <p:cNvSpPr/>
+          <p:nvPr/>
+        </p:nvSpPr>
+        <p:spPr>
+          <a:xfrm>
+            <a:off x="2953512" y="5696712"/>
+            <a:ext cx="2048256" cy="292608"/>
+          </a:xfrm>
+          <a:prstGeom prst="rect">
+            <a:avLst/>
+          </a:prstGeom>
+          <a:noFill/>
+          <a:ln/>
+        </p:spPr>
+        <p:txBody>
+          <a:bodyPr wrap="square" lIns="0" tIns="0" rIns="0" bIns="0" rtlCol="0" anchor="ctr"/>
+          <a:lstStyle/>
+          <a:p>
+            <a:pPr indent="0" marL="0">
+              <a:buNone/>
+            </a:pPr>
+            <a:r>
+              <a:rPr lang="en-US" sz="1700" b="1" dirty="0">
+                <a:solidFill>
+                  <a:srgbClr val="346A55"/>
+                </a:solidFill>
+                <a:latin typeface="Noto Sans CJK SC" pitchFamily="34" charset="0"/>
+                <a:ea typeface="Noto Sans CJK SC" pitchFamily="34" charset="-122"/>
+                <a:cs typeface="Noto Sans CJK SC" pitchFamily="34" charset="-120"/>
+              </a:rPr>
+              <a:t>林新淇</a:t>
+            </a:r>
+            <a:endParaRPr lang="en-US" sz="1700" dirty="0"/>
+          </a:p>
+        </p:txBody>
+      </p:sp>
+      <p:sp>
+        <p:nvSpPr>
+          <p:cNvPr id="19" name="Text 16"/>
+          <p:cNvSpPr/>
+          <p:nvPr/>
+        </p:nvSpPr>
+        <p:spPr>
+          <a:xfrm>
+            <a:off x="2953512" y="6089904"/>
+            <a:ext cx="2048256" cy="429768"/>
+          </a:xfrm>
+          <a:prstGeom prst="rect">
+            <a:avLst/>
+          </a:prstGeom>
+          <a:noFill/>
+          <a:ln/>
+        </p:spPr>
+        <p:txBody>
+          <a:bodyPr wrap="square" lIns="0" tIns="0" rIns="0" bIns="0" rtlCol="0" anchor="ctr"/>
+          <a:lstStyle/>
+          <a:p>
+            <a:pPr indent="0" marL="0">
+              <a:buNone/>
+            </a:pPr>
+            <a:r>
+              <a:rPr lang="en-US" sz="1250" dirty="0">
+                <a:solidFill>
+                  <a:srgbClr val="66736D"/>
+                </a:solidFill>
+                <a:latin typeface="Noto Sans" pitchFamily="34" charset="0"/>
+                <a:ea typeface="Noto Sans" pitchFamily="34" charset="-122"/>
+                <a:cs typeface="Noto Sans" pitchFamily="34" charset="-120"/>
+              </a:rPr>
+              <a:t>Materials &amp;</a:t>
+            </a:r>
+            <a:endParaRPr lang="en-US" sz="1250" dirty="0"/>
+          </a:p>
+          <a:p>
+            <a:pPr indent="0" marL="0">
+              <a:buNone/>
+            </a:pPr>
+            <a:r>
+              <a:rPr lang="en-US" sz="1250" dirty="0">
+                <a:solidFill>
+                  <a:srgbClr val="66736D"/>
+                </a:solidFill>
+                <a:latin typeface="Noto Sans" pitchFamily="34" charset="0"/>
+                <a:ea typeface="Noto Sans" pitchFamily="34" charset="-122"/>
+                <a:cs typeface="Noto Sans" pitchFamily="34" charset="-120"/>
+              </a:rPr>
+              <a:t>construction</a:t>
+            </a:r>
+            <a:endParaRPr lang="en-US" sz="1250" dirty="0"/>
+          </a:p>
+        </p:txBody>
+      </p:sp>
+      <p:sp>
+        <p:nvSpPr>
+          <p:cNvPr id="20" name="Text 17"/>
+          <p:cNvSpPr/>
+          <p:nvPr/>
+        </p:nvSpPr>
+        <p:spPr>
+          <a:xfrm>
+            <a:off x="5221224" y="5696712"/>
+            <a:ext cx="2048256" cy="292608"/>
+          </a:xfrm>
+          <a:prstGeom prst="rect">
+            <a:avLst/>
+          </a:prstGeom>
+          <a:noFill/>
+          <a:ln/>
+        </p:spPr>
+        <p:txBody>
+          <a:bodyPr wrap="square" lIns="0" tIns="0" rIns="0" bIns="0" rtlCol="0" anchor="ctr"/>
+          <a:lstStyle/>
+          <a:p>
+            <a:pPr indent="0" marL="0">
+              <a:buNone/>
+            </a:pPr>
+            <a:r>
+              <a:rPr lang="en-US" sz="1700" b="1" dirty="0">
+                <a:solidFill>
+                  <a:srgbClr val="346A55"/>
+                </a:solidFill>
+                <a:latin typeface="Noto Sans CJK SC" pitchFamily="34" charset="0"/>
+                <a:ea typeface="Noto Sans CJK SC" pitchFamily="34" charset="-122"/>
+                <a:cs typeface="Noto Sans CJK SC" pitchFamily="34" charset="-120"/>
+              </a:rPr>
+              <a:t>虞寒哲</a:t>
+            </a:r>
+            <a:endParaRPr lang="en-US" sz="1700" dirty="0"/>
+          </a:p>
+        </p:txBody>
+      </p:sp>
+      <p:sp>
+        <p:nvSpPr>
+          <p:cNvPr id="21" name="Text 18"/>
+          <p:cNvSpPr/>
+          <p:nvPr/>
+        </p:nvSpPr>
+        <p:spPr>
+          <a:xfrm>
+            <a:off x="5221224" y="6089904"/>
+            <a:ext cx="2048256" cy="429768"/>
+          </a:xfrm>
+          <a:prstGeom prst="rect">
+            <a:avLst/>
+          </a:prstGeom>
+          <a:noFill/>
+          <a:ln/>
+        </p:spPr>
+        <p:txBody>
+          <a:bodyPr wrap="square" lIns="0" tIns="0" rIns="0" bIns="0" rtlCol="0" anchor="ctr"/>
+          <a:lstStyle/>
+          <a:p>
+            <a:pPr indent="0" marL="0">
+              <a:buNone/>
+            </a:pPr>
+            <a:r>
+              <a:rPr lang="en-US" sz="1250" dirty="0">
+                <a:solidFill>
+                  <a:srgbClr val="66736D"/>
+                </a:solidFill>
+                <a:latin typeface="Noto Sans" pitchFamily="34" charset="0"/>
+                <a:ea typeface="Noto Sans" pitchFamily="34" charset="-122"/>
+                <a:cs typeface="Noto Sans" pitchFamily="34" charset="-120"/>
+              </a:rPr>
+              <a:t>Shade performance</a:t>
+            </a:r>
+            <a:endParaRPr lang="en-US" sz="1250" dirty="0"/>
+          </a:p>
+          <a:p>
+            <a:pPr indent="0" marL="0">
+              <a:buNone/>
+            </a:pPr>
+            <a:r>
+              <a:rPr lang="en-US" sz="1250" dirty="0">
+                <a:solidFill>
+                  <a:srgbClr val="66736D"/>
+                </a:solidFill>
+                <a:latin typeface="Noto Sans" pitchFamily="34" charset="0"/>
+                <a:ea typeface="Noto Sans" pitchFamily="34" charset="-122"/>
+                <a:cs typeface="Noto Sans" pitchFamily="34" charset="-120"/>
+              </a:rPr>
+              <a:t>&amp; application</a:t>
+            </a:r>
+            <a:endParaRPr lang="en-US" sz="1250" dirty="0"/>
+          </a:p>
+        </p:txBody>
+      </p:sp>
+      <p:sp>
+        <p:nvSpPr>
+          <p:cNvPr id="22" name="Text 19"/>
+          <p:cNvSpPr/>
+          <p:nvPr/>
+        </p:nvSpPr>
+        <p:spPr>
+          <a:xfrm>
+            <a:off x="7488936" y="5696712"/>
+            <a:ext cx="2048256" cy="292608"/>
+          </a:xfrm>
+          <a:prstGeom prst="rect">
+            <a:avLst/>
+          </a:prstGeom>
+          <a:noFill/>
+          <a:ln/>
+        </p:spPr>
+        <p:txBody>
+          <a:bodyPr wrap="square" lIns="0" tIns="0" rIns="0" bIns="0" rtlCol="0" anchor="ctr"/>
+          <a:lstStyle/>
+          <a:p>
+            <a:pPr indent="0" marL="0">
+              <a:buNone/>
+            </a:pPr>
+            <a:r>
+              <a:rPr lang="en-US" sz="1700" b="1" dirty="0">
+                <a:solidFill>
+                  <a:srgbClr val="346A55"/>
+                </a:solidFill>
+                <a:latin typeface="Noto Sans CJK SC" pitchFamily="34" charset="0"/>
+                <a:ea typeface="Noto Sans CJK SC" pitchFamily="34" charset="-122"/>
+                <a:cs typeface="Noto Sans CJK SC" pitchFamily="34" charset="-120"/>
+              </a:rPr>
+              <a:t>徐世程</a:t>
+            </a:r>
+            <a:endParaRPr lang="en-US" sz="1700" dirty="0"/>
+          </a:p>
+        </p:txBody>
+      </p:sp>
+      <p:sp>
+        <p:nvSpPr>
+          <p:cNvPr id="23" name="Text 20"/>
+          <p:cNvSpPr/>
+          <p:nvPr/>
+        </p:nvSpPr>
+        <p:spPr>
+          <a:xfrm>
+            <a:off x="7488936" y="6089904"/>
+            <a:ext cx="2048256" cy="429768"/>
+          </a:xfrm>
+          <a:prstGeom prst="rect">
+            <a:avLst/>
+          </a:prstGeom>
+          <a:noFill/>
+          <a:ln/>
+        </p:spPr>
+        <p:txBody>
+          <a:bodyPr wrap="square" lIns="0" tIns="0" rIns="0" bIns="0" rtlCol="0" anchor="ctr"/>
+          <a:lstStyle/>
+          <a:p>
+            <a:pPr indent="0" marL="0">
+              <a:buNone/>
+            </a:pPr>
+            <a:r>
+              <a:rPr lang="en-US" sz="1250" dirty="0">
+                <a:solidFill>
+                  <a:srgbClr val="66736D"/>
+                </a:solidFill>
+                <a:latin typeface="Noto Sans" pitchFamily="34" charset="0"/>
+                <a:ea typeface="Noto Sans" pitchFamily="34" charset="-122"/>
+                <a:cs typeface="Noto Sans" pitchFamily="34" charset="-120"/>
+              </a:rPr>
+              <a:t>PPT production</a:t>
+            </a:r>
+            <a:endParaRPr lang="en-US" sz="1250" dirty="0"/>
+          </a:p>
+          <a:p>
+            <a:pPr indent="0" marL="0">
+              <a:buNone/>
+            </a:pPr>
+            <a:r>
+              <a:rPr lang="en-US" sz="1250" dirty="0">
+                <a:solidFill>
+                  <a:srgbClr val="66736D"/>
+                </a:solidFill>
+                <a:latin typeface="Noto Sans" pitchFamily="34" charset="0"/>
+                <a:ea typeface="Noto Sans" pitchFamily="34" charset="-122"/>
+                <a:cs typeface="Noto Sans" pitchFamily="34" charset="-120"/>
+              </a:rPr>
+              <a:t>&amp; integration</a:t>
+            </a:r>
+            <a:endParaRPr lang="en-US" sz="1250" dirty="0"/>
+          </a:p>
+        </p:txBody>
+      </p:sp>
+      <p:sp>
+        <p:nvSpPr>
+          <p:cNvPr id="24" name="Text 21"/>
+          <p:cNvSpPr/>
+          <p:nvPr/>
+        </p:nvSpPr>
+        <p:spPr>
+          <a:xfrm>
+            <a:off x="9756648" y="5696712"/>
+            <a:ext cx="2048256" cy="292608"/>
+          </a:xfrm>
+          <a:prstGeom prst="rect">
+            <a:avLst/>
+          </a:prstGeom>
+          <a:noFill/>
+          <a:ln/>
+        </p:spPr>
+        <p:txBody>
+          <a:bodyPr wrap="square" lIns="0" tIns="0" rIns="0" bIns="0" rtlCol="0" anchor="ctr"/>
+          <a:lstStyle/>
+          <a:p>
+            <a:pPr indent="0" marL="0">
+              <a:buNone/>
+            </a:pPr>
+            <a:r>
+              <a:rPr lang="en-US" sz="1700" b="1" dirty="0">
+                <a:solidFill>
+                  <a:srgbClr val="346A55"/>
+                </a:solidFill>
+                <a:latin typeface="Noto Sans CJK SC" pitchFamily="34" charset="0"/>
+                <a:ea typeface="Noto Sans CJK SC" pitchFamily="34" charset="-122"/>
+                <a:cs typeface="Noto Sans CJK SC" pitchFamily="34" charset="-120"/>
+              </a:rPr>
+              <a:t>陈淼</a:t>
+            </a:r>
+            <a:endParaRPr lang="en-US" sz="1700" dirty="0"/>
+          </a:p>
+        </p:txBody>
+      </p:sp>
+      <p:sp>
+        <p:nvSpPr>
+          <p:cNvPr id="25" name="Text 22"/>
+          <p:cNvSpPr/>
+          <p:nvPr/>
+        </p:nvSpPr>
+        <p:spPr>
+          <a:xfrm>
+            <a:off x="9756648" y="6089904"/>
+            <a:ext cx="2048256" cy="429768"/>
+          </a:xfrm>
+          <a:prstGeom prst="rect">
+            <a:avLst/>
+          </a:prstGeom>
+          <a:noFill/>
+          <a:ln/>
+        </p:spPr>
+        <p:txBody>
+          <a:bodyPr wrap="square" lIns="0" tIns="0" rIns="0" bIns="0" rtlCol="0" anchor="ctr"/>
+          <a:lstStyle/>
+          <a:p>
+            <a:pPr indent="0" marL="0">
+              <a:buNone/>
+            </a:pPr>
+            <a:r>
+              <a:rPr lang="en-US" sz="1250" dirty="0">
+                <a:solidFill>
+                  <a:srgbClr val="66736D"/>
+                </a:solidFill>
+                <a:latin typeface="Noto Sans" pitchFamily="34" charset="0"/>
+                <a:ea typeface="Noto Sans" pitchFamily="34" charset="-122"/>
+                <a:cs typeface="Noto Sans" pitchFamily="34" charset="-120"/>
+              </a:rPr>
+              <a:t>English presentation</a:t>
+            </a:r>
+            <a:endParaRPr lang="en-US" sz="1250" dirty="0"/>
+          </a:p>
+          <a:p>
+            <a:pPr indent="0" marL="0">
+              <a:buNone/>
+            </a:pPr>
+            <a:r>
+              <a:rPr lang="en-US" sz="1250" dirty="0">
+                <a:solidFill>
+                  <a:srgbClr val="66736D"/>
+                </a:solidFill>
+                <a:latin typeface="Noto Sans" pitchFamily="34" charset="0"/>
+                <a:ea typeface="Noto Sans" pitchFamily="34" charset="-122"/>
+                <a:cs typeface="Noto Sans" pitchFamily="34" charset="-120"/>
+              </a:rPr>
+              <a:t>&amp; Q&amp;A</a:t>
+            </a:r>
+            <a:endParaRPr lang="en-US" sz="1250" dirty="0"/>
+          </a:p>
+        </p:txBody>
+      </p:sp>
     </p:spTree>
   </p:cSld>
   <p:clrMapOvr>

</xml_diff>